<commit_message>
slides, instructor: S4 and final from the quiet runs; release build of the deck
S4 demo block from the quiet run of make show-4, final results slides 64-66
with a Mermaid flow and the quiet make final FEATURES=F5 screens. Run sheet,
instructor guide, and fallbacks carry the quiet-run times and costs. Rebuilt
with make slides SLIDES_OPTS=--strict (72 slides, 72 PDF pages, 0 open items)
and copied dist/deck.pdf and dist/deck.pptx.
</commit_message>
<xml_diff>
--- a/slides/deck.pptx
+++ b/slides/deck.pptx
@@ -1315,12 +1315,7 @@
           </a:p>
           <a:p>
             <a:r>
-              <a:t>timing reference is in the notes of slide 9). Once it is there, start the replay for slide 19 in</a:t>
-            </a:r>
-          </a:p>
-          <a:p>
-            <a:r>
-              <a:t>terminal B: `make replay RUN=ab-20261016-212252-aa1644`.</a:t>
+              <a:t>timing reference is in the notes of slide 9).</a:t>
             </a:r>
           </a:p>
           <a:p/>
@@ -1494,22 +1489,47 @@
           <a:p/>
           <a:p>
             <a:r>
-              <a:t>Every screen of the replay shows RECORDING. Say: "The referee probes every endpoint as Acme with</a:t>
-            </a:r>
-          </a:p>
-          <a:p>
-            <a:r>
-              <a:t>Globex ids and expects 404. It does not care which arm wrote the code, or whether the arm had a map."</a:t>
-            </a:r>
-          </a:p>
-          <a:p>
-            <a:r>
-              <a:t>The replayed run: pilot run 3, F4, A/B ab-20261016-212252-aa1644, harness arm hidden tests 27 of 69</a:t>
-            </a:r>
-          </a:p>
-          <a:p>
-            <a:r>
-              <a:t>and 3 new R1 violations. If the replay's referee is still running, walk through screens 1 and 3 first.</a:t>
+              <a:t>Walk the finished show-1 run on screens 1, 3, 5, and 2, in that order. In the quiet run (captured on</a:t>
+            </a:r>
+          </a:p>
+          <a:p>
+            <a:r>
+              <a:t>2026-10-17, run ab-20261017-112101-c5d839; your output will differ): by minute 1 the build session was</a:t>
+            </a:r>
+          </a:p>
+          <a:p>
+            <a:r>
+              <a:t>patching app/api/issues.py and app/services/issues.py; by minute 3 the test phase had run and the</a:t>
+            </a:r>
+          </a:p>
+          <a:p>
+            <a:r>
+              <a:t>agent said done; at 4:11 screen 1 showed "primary verdict ready: PASS" with new R1 violations 0; the</a:t>
+            </a:r>
+          </a:p>
+          <a:p>
+            <a:r>
+              <a:t>secondary checks finished at 10:00. Its harness decisions: 31 instruction files placed (the AGENTS.md</a:t>
+            </a:r>
+          </a:p>
+          <a:p>
+            <a:r>
+              <a:t>map, docs, skills), the agent read ARCHITECTURE.md and the add-endpoint skill. Its third tool call</a:t>
+            </a:r>
+          </a:p>
+          <a:p>
+            <a:r>
+              <a:t>opened docs/HANDBOOK.md, the same file every bare arm of run 2 opened with its third call. Screen 2</a:t>
+            </a:r>
+          </a:p>
+          <a:p>
+            <a:r>
+              <a:t>shows one board frame: F1 changes no board pixels. The image is cut to the harness panel (the bare</a:t>
+            </a:r>
+          </a:p>
+          <a:p>
+            <a:r>
+              <a:t>panel is empty in a show run).</a:t>
             </a:r>
           </a:p>
           <a:p/>
@@ -1520,7 +1540,7 @@
           </a:p>
           <a:p>
             <a:r>
-              <a:t>Source: README.md §11; Makefile `show-1`, `replay`.</a:t>
+              <a:t>Source: quiet run ab-20261017-112101-c5d839 (screens 1 and 2); README.md §11; Makefile `show-1`.</a:t>
             </a:r>
           </a:p>
         </p:txBody>
@@ -1708,6 +1728,22 @@
           <a:p/>
           <a:p>
             <a:r>
+              <a:t>Read tonight's verdict from screen 1 first, then this slide. The quiet run's arm line (captured on</a:t>
+            </a:r>
+          </a:p>
+          <a:p>
+            <a:r>
+              <a:t>2026-10-17, run ab-20261017-112101-c5d839; your output will differ): `harness completed claim=done</a:t>
+            </a:r>
+          </a:p>
+          <a:p>
+            <a:r>
+              <a:t>primary={"r1_new_violations": 0} passed=True hidden 52/52 mutants 2/4 reviewer=accept cost=$0.0179`.</a:t>
+            </a:r>
+          </a:p>
+          <a:p/>
+          <a:p>
+            <a:r>
               <a:t>The 7 runs per arm: run 3, effort medium (A/Bs ab-20261016-211419-07937b, ab-20261016-212745-2c14fb,</a:t>
             </a:r>
           </a:p>
@@ -1723,17 +1759,22 @@
           </a:p>
           <a:p>
             <a:r>
-              <a:t>ticket gave the same, 0 of 3 per arm. "Post hoc" means chosen after the results were known:</a:t>
-            </a:r>
-          </a:p>
-          <a:p>
-            <a:r>
-              <a:t>descriptive, never a test; the 10 runs per arm are run 2, the live console check, run 3, and run 4.</a:t>
-            </a:r>
-          </a:p>
-          <a:p>
-            <a:r>
-              <a:t>[[CAPTURE: what make example-1 shows on each console screen, and its wall time | how: make example-1]]</a:t>
+              <a:t>ticket gave the same, 0 of 3 per arm. Why: in run 2 every bare arm opened the handbook with its third</a:t>
+            </a:r>
+          </a:p>
+          <a:p>
+            <a:r>
+              <a:t>tool call; no arm copied the legacy handler into a leak. Post hoc, descriptive (10 runs per arm: run</a:t>
+            </a:r>
+          </a:p>
+          <a:p>
+            <a:r>
+              <a:t>2, the live console check, run 3, run 4): done claimed by harness 5, bare 9; median cost $0.0122</a:t>
+            </a:r>
+          </a:p>
+          <a:p>
+            <a:r>
+              <a:t>against $0.0103. "Post hoc" means chosen after the results were known: descriptive, never a test.</a:t>
             </a:r>
           </a:p>
           <a:p/>
@@ -1744,7 +1785,7 @@
           </a:p>
           <a:p>
             <a:r>
-              <a:t>Source: course pilot runs 2-4 and class-profile round (A/B ids above); submodules/01-instructions/concepts.md (third tool call).</a:t>
+              <a:t>Source: quiet run ab-20261017-112101-c5d839 (screen 3); course pilot runs 2-4 and class-profile round (A/B ids above); submodules/01-instructions/concepts.md (third tool call).</a:t>
             </a:r>
           </a:p>
         </p:txBody>
@@ -2010,17 +2051,32 @@
           <a:p/>
           <a:p>
             <a:r>
-              <a:t>Timing reference: in the class-profile round (A/B ab-20261017-085139-7c0661), the harness arm's</a:t>
-            </a:r>
-          </a:p>
-          <a:p>
-            <a:r>
-              <a:t>primary verdict came 358 s after launch and its full verdict 533 s after launch.</a:t>
-            </a:r>
-          </a:p>
-          <a:p>
-            <a:r>
-              <a:t>[[CAPTURE: wall time of make show-2 on the class host, launch to the primary verdict and to the full verdict | how: make show-2 SESSION_BUDGET=12,38]]</a:t>
+              <a:t>Timing reference: in the quiet run of `make show-2 SESSION_BUDGET=12,38` (captured on 2026-10-17, run</a:t>
+            </a:r>
+          </a:p>
+          <a:p>
+            <a:r>
+              <a:t>ab-20261017-113213-fe89a3; your output will differ) the primary verdict came 6:46 after launch, the</a:t>
+            </a:r>
+          </a:p>
+          <a:p>
+            <a:r>
+              <a:t>full verdict 9:52 after launch, and the command took 10 min 7 s in all. It exited 2: session 2 hit</a:t>
+            </a:r>
+          </a:p>
+          <a:p>
+            <a:r>
+              <a:t>the agent time limit (a result, not a failure of the command). In the class-profile round (A/B</a:t>
+            </a:r>
+          </a:p>
+          <a:p>
+            <a:r>
+              <a:t>ab-20261017-085139-7c0661) the harness arm's primary verdict came 358 s and its full verdict 533 s</a:t>
+            </a:r>
+          </a:p>
+          <a:p>
+            <a:r>
+              <a:t>after launch.</a:t>
             </a:r>
           </a:p>
           <a:p/>
@@ -2751,12 +2807,7 @@
           </a:p>
           <a:p>
             <a:r>
-              <a:t>timing reference is in the notes of slide 23). Once it is there, start the replay for slide 32 in</a:t>
-            </a:r>
-          </a:p>
-          <a:p>
-            <a:r>
-              <a:t>terminal B: `make replay RUN=ab-20261016-213317-9a0ec1`.</a:t>
+              <a:t>timing reference is in the notes of slide 23).</a:t>
             </a:r>
           </a:p>
           <a:p/>
@@ -2930,27 +2981,57 @@
           <a:p/>
           <a:p>
             <a:r>
-              <a:t>The replayed run: pilot run 3, F2, A/B ab-20261016-213317-9a0ec1, harness arm hidden tests 3 of 56.</a:t>
-            </a:r>
-          </a:p>
-          <a:p>
-            <a:r>
-              <a:t>The same early finish happened in ab-20261016-214959-de790f (run 3) and, in run 4 (effort low), in</a:t>
-            </a:r>
-          </a:p>
-          <a:p>
-            <a:r>
-              <a:t>the bare arm of all three A/Bs and in one harness arm. The fix is a bug fix that applies to both arms;</a:t>
-            </a:r>
-          </a:p>
-          <a:p>
-            <a:r>
-              <a:t>the class-profile round ran with it. Follow-up question: which file did session 2 read first, and did</a:t>
-            </a:r>
-          </a:p>
-          <a:p>
-            <a:r>
-              <a:t>it change what that session did next?</a:t>
+              <a:t>In the quiet run (captured on 2026-10-17, run ab-20261017-113213-fe89a3; your output will differ),</a:t>
+            </a:r>
+          </a:p>
+          <a:p>
+            <a:r>
+              <a:t>about 2 minutes after launch: turn 1.11 ran `git add progress.md docs/exec-plans/active/...`, turn</a:t>
+            </a:r>
+          </a:p>
+          <a:p>
+            <a:r>
+              <a:t>1.12 called</a:t>
+            </a:r>
+          </a:p>
+          <a:p>
+            <a:r>
+              <a:t>`finish not_done`, and screen 1 showed "Session 1 stopped: ended by claim_not_done; handoff</a:t>
+            </a:r>
+          </a:p>
+          <a:p>
+            <a:r>
+              <a:t>session-handoff.md", then "Session 2 resumed: prefix: core, instructions, state". Since change 14</a:t>
+            </a:r>
+          </a:p>
+          <a:p>
+            <a:r>
+              <a:t>(both arms) that call ends only the session, so session 2 ran; in pilot run 3 the same call ended</a:t>
+            </a:r>
+          </a:p>
+          <a:p>
+            <a:r>
+              <a:t>the build phase (A/B ab-20261016-213317-9a0ec1, hidden tests 3 of 56). Session 2 began with `pwd; git</a:t>
+            </a:r>
+          </a:p>
+          <a:p>
+            <a:r>
+              <a:t>log --oneline -20; cat progress.md`, then the ticket and the handbook. The harness decisions show</a:t>
+            </a:r>
+          </a:p>
+          <a:p>
+            <a:r>
+              <a:t>the initializer step (init.sh, progress.md, session-handoff.md) and "session 1 handoff written to</a:t>
+            </a:r>
+          </a:p>
+          <a:p>
+            <a:r>
+              <a:t>session-handoff.md". The board (screen 2) showed "✓ only own-org cards, no duplicates". The image is</a:t>
+            </a:r>
+          </a:p>
+          <a:p>
+            <a:r>
+              <a:t>cut to the harness panel.</a:t>
             </a:r>
           </a:p>
           <a:p/>
@@ -2961,7 +3042,7 @@
           </a:p>
           <a:p>
             <a:r>
-              <a:t>Source: README.md §11; Makefile `show-2`, `replay`.</a:t>
+              <a:t>Source: quiet run ab-20261017-113213-fe89a3 (screen 1); README.md §11; Makefile `show-2`.</a:t>
             </a:r>
           </a:p>
         </p:txBody>
@@ -3037,6 +3118,37 @@
           <a:p/>
           <a:p>
             <a:r>
+              <a:t>The quiet run's arm line (captured on 2026-10-17, run ab-20261017-113213-fe89a3; your output will</a:t>
+            </a:r>
+          </a:p>
+          <a:p>
+            <a:r>
+              <a:t>differ): `harness ABORTED: timeout claim=not_done primary={"continuity_failure": false} passed=True</a:t>
+            </a:r>
+          </a:p>
+          <a:p>
+            <a:r>
+              <a:t>hidden 56/56 mutants 0/4 reviewer=reject cost=$0.0268`. Sessions: 12 turns (claim_not_done), then</a:t>
+            </a:r>
+          </a:p>
+          <a:p>
+            <a:r>
+              <a:t>31. The diff-scope check is a secondary measure, and the F2 harness arm has no scope layer, so</a:t>
+            </a:r>
+          </a:p>
+          <a:p>
+            <a:r>
+              <a:t>nothing stopped that edit. Exit code 2 means the arm was aborted at a time limit, not that the</a:t>
+            </a:r>
+          </a:p>
+          <a:p>
+            <a:r>
+              <a:t>command broke.</a:t>
+            </a:r>
+          </a:p>
+          <a:p/>
+          <a:p>
+            <a:r>
               <a:t>The 7 A/Bs: run 3 (ab-20261016-211419-dfe06f, ab-20261016-213317-9a0ec1, ab-20261016-214959-de790f),</a:t>
             </a:r>
           </a:p>
@@ -3057,12 +3169,22 @@
           </a:p>
           <a:p>
             <a:r>
-              <a:t>ab-20261016-234027-226a76. The `git status` call: run 2, A/B ab-20261016-181736-08a9c4, run</a:t>
-            </a:r>
-          </a:p>
-          <a:p>
-            <a:r>
-              <a:t>r-20261016-181736-a05ddb. Post hoc rows: runs 2-4, 9 runs per arm.</a:t>
+              <a:t>ab-20261016-234027-226a76. The bare arm found its own state: in run 2 (A/B ab-20261016-181736-08a9c4,</a:t>
+            </a:r>
+          </a:p>
+          <a:p>
+            <a:r>
+              <a:t>run r-20261016-181736-a05ddb) its session 2 ran `git status` in its fourth tool call. Post hoc,</a:t>
+            </a:r>
+          </a:p>
+          <a:p>
+            <a:r>
+              <a:t>descriptive (runs 2-4, 9 runs per arm): agent time limit hit, harness 4, bare 0; median wall 361 s</a:t>
+            </a:r>
+          </a:p>
+          <a:p>
+            <a:r>
+              <a:t>against 232 s. Class-profile round, with the fix: both arms built the feature, 56 of 56 hidden tests.</a:t>
             </a:r>
           </a:p>
           <a:p/>
@@ -3076,11 +3198,6 @@
               <a:t>run because the pre-registered pilot gate did not pass.</a:t>
             </a:r>
           </a:p>
-          <a:p>
-            <a:r>
-              <a:t>[[CAPTURE: what make example-2 shows on each console screen, and its wall time | how: make example-2]]</a:t>
-            </a:r>
-          </a:p>
           <a:p/>
           <a:p>
             <a:r>
@@ -3089,7 +3206,7 @@
           </a:p>
           <a:p>
             <a:r>
-              <a:t>Source: course pilot runs 2-4 and class-profile round (A/B ids above); submodules/02-state-lifecycle/concepts.md (git status).</a:t>
+              <a:t>Source: quiet run ab-20261017-113213-fe89a3 (screens 3 and 5); course pilot runs 2-4 and class-profile round (A/B ids above); submodules/02-state-lifecycle/concepts.md (git status).</a:t>
             </a:r>
           </a:p>
         </p:txBody>
@@ -3431,17 +3548,33 @@
           <a:p/>
           <a:p>
             <a:r>
-              <a:t>Timing reference: in the class-profile round (A/B ab-20261017-090051-91f837), the harness arm's</a:t>
-            </a:r>
-          </a:p>
-          <a:p>
-            <a:r>
-              <a:t>primary verdict came 317 s after launch and its full verdict 481 s after launch.</a:t>
-            </a:r>
-          </a:p>
-          <a:p>
-            <a:r>
-              <a:t>[[CAPTURE: wall time of make show-3 on the class host, launch to the primary verdict and to the full verdict | how: make show-3]]</a:t>
+              <a:t>Harness arm layers: instructions, state, scope.</a:t>
+            </a:r>
+          </a:p>
+          <a:p/>
+          <a:p>
+            <a:r>
+              <a:t>Timing reference: in the quiet run of `make show-3` (captured on 2026-10-17, run</a:t>
+            </a:r>
+          </a:p>
+          <a:p>
+            <a:r>
+              <a:t>ab-20261017-114259-b64f54; your output will differ) the primary verdict came 4:25 after launch, the</a:t>
+            </a:r>
+          </a:p>
+          <a:p>
+            <a:r>
+              <a:t>full verdict 7:31 after launch, and the command took 7 min 43 s in all (exit 0). In the</a:t>
+            </a:r>
+          </a:p>
+          <a:p>
+            <a:r>
+              <a:t>class-profile round (A/B ab-20261017-090051-91f837) the harness arm's primary verdict came 317 s and</a:t>
+            </a:r>
+          </a:p>
+          <a:p>
+            <a:r>
+              <a:t>its full verdict 481 s after launch.</a:t>
             </a:r>
           </a:p>
           <a:p/>
@@ -4177,12 +4310,7 @@
           </a:p>
           <a:p>
             <a:r>
-              <a:t>(the timing reference is in the notes of slide 37). Once it is there, start the replay for slide 46</a:t>
-            </a:r>
-          </a:p>
-          <a:p>
-            <a:r>
-              <a:t>in terminal B: `make replay RUN=ab-20261016-214151-ca9841`.</a:t>
+              <a:t>(the timing reference is in the notes of slide 37).</a:t>
             </a:r>
           </a:p>
           <a:p/>
@@ -4356,17 +4484,42 @@
           <a:p/>
           <a:p>
             <a:r>
-              <a:t>The replayed run: pilot run 3, F4, A/B ab-20261016-214151-ca9841. F4 runs all four layers, so the</a:t>
-            </a:r>
-          </a:p>
-          <a:p>
-            <a:r>
-              <a:t>scope layer is in its harness arm. Follow-up: the harness arm cannot leave the allowed paths by</a:t>
-            </a:r>
-          </a:p>
-          <a:p>
-            <a:r>
-              <a:t>construction. What would make you trust that it also shipped a working feature?</a:t>
+              <a:t>In the quiet run (captured on 2026-10-17, run ab-20261017-114259-b64f54; your output will differ)</a:t>
+            </a:r>
+          </a:p>
+          <a:p>
+            <a:r>
+              <a:t>the agent began with `pwd; git status --short; git log --oneline`, read the ticket, then</a:t>
+            </a:r>
+          </a:p>
+          <a:p>
+            <a:r>
+              <a:t>`cat docs/QUALITY_SCORE.md`. It never tried an edit outside the allow list: no ⊘ block, no ↺</a:t>
+            </a:r>
+          </a:p>
+          <a:p>
+            <a:r>
+              <a:t>revert, and no sandbox denial. The harness decisions were the 31 instruction files, the initializer</a:t>
+            </a:r>
+          </a:p>
+          <a:p>
+            <a:r>
+              <a:t>step, and "feature_list.json written with F3 (passes: false)". Sessions: build 18 turns, test 12.</a:t>
+            </a:r>
+          </a:p>
+          <a:p>
+            <a:r>
+              <a:t>If tonight's run blocks an edit, read its reason aloud: it is what the agent read in its tool result,</a:t>
+            </a:r>
+          </a:p>
+          <a:p>
+            <a:r>
+              <a:t>and it names the phase and the allowed paths. If it records a `sandbox_denied` event, show its reason</a:t>
+            </a:r>
+          </a:p>
+          <a:p>
+            <a:r>
+              <a:t>code and command; otherwise show the policy printout. The image is cut to the harness panel.</a:t>
             </a:r>
           </a:p>
           <a:p/>
@@ -4377,7 +4530,7 @@
           </a:p>
           <a:p>
             <a:r>
-              <a:t>Source: README.md §11; Makefile `show-3`, `replay`.</a:t>
+              <a:t>Source: quiet run ab-20261017-114259-b64f54 (screen 1); README.md §11; Makefile `show-3`.</a:t>
             </a:r>
           </a:p>
         </p:txBody>
@@ -4453,6 +4606,32 @@
           <a:p/>
           <a:p>
             <a:r>
+              <a:t>The quiet run's arm line (captured on 2026-10-17, run ab-20261017-114259-b64f54; your output will</a:t>
+            </a:r>
+          </a:p>
+          <a:p>
+            <a:r>
+              <a:t>differ): `harness completed claim=done primary={"out_of_scope_files": 0, "test_phase_source_edits":</a:t>
+            </a:r>
+          </a:p>
+          <a:p>
+            <a:r>
+              <a:t>0} passed=True hidden 49/49 mutants 4/4 reviewer=reject cost=$0.0142`. Its diff map: app/api/issues.py,</a:t>
+            </a:r>
+          </a:p>
+          <a:p>
+            <a:r>
+              <a:t>app/services/issues.py, docs/HANDBOOK.md, tests/visible/test_issue_idempotency.py, all inside the</a:t>
+            </a:r>
+          </a:p>
+          <a:p>
+            <a:r>
+              <a:t>build allow list. Sandbox denials: none.</a:t>
+            </a:r>
+          </a:p>
+          <a:p/>
+          <a:p>
+            <a:r>
               <a:t>The 7 A/Bs: run 3 (ab-20261016-212115-a361f5, ab-20261016-213624-d7eb13, ab-20261016-215443-f2c188),</a:t>
             </a:r>
           </a:p>
@@ -4463,32 +4642,37 @@
           </a:p>
           <a:p>
             <a:r>
-              <a:t>class-profile round (ab-20261017-090051-91f837). Post hoc F4 rows: runs 2 and 3 (6 runs per arm).</a:t>
-            </a:r>
-          </a:p>
-          <a:p>
-            <a:r>
-              <a:t>On F2 the harness arms also stayed inside the allowed paths (0 of 9), but demo-2 has no scope layer,</a:t>
-            </a:r>
-          </a:p>
-          <a:p>
-            <a:r>
-              <a:t>so that is not the scope layer's doing. Sandbox: no `sandbox_denied` event in any recorded pilot A/B</a:t>
-            </a:r>
-          </a:p>
-          <a:p>
-            <a:r>
-              <a:t>(checked on 2026-10-17 with `grep -l sandbox_denied .shipharness/runs/*/events.jsonl`). If</a:t>
-            </a:r>
-          </a:p>
-          <a:p>
-            <a:r>
-              <a:t>tonight's `make show-3` recorded one, show its reason code and command first.</a:t>
-            </a:r>
-          </a:p>
-          <a:p>
-            <a:r>
-              <a:t>[[CAPTURE: what make example-3 shows on each console screen, and its wall time | how: make example-3]]</a:t>
+              <a:t>class-profile round (ab-20261017-090051-91f837). Post hoc, F3 (9 runs per arm): harness arms</a:t>
+            </a:r>
+          </a:p>
+          <a:p>
+            <a:r>
+              <a:t>shipped a median of 0 tests against 6; claimed done in 4 against 9. Post hoc, F4 (all four layers;</a:t>
+            </a:r>
+          </a:p>
+          <a:p>
+            <a:r>
+              <a:t>runs 2 and 3, 6 runs per arm): bare arms left the allowed paths in 6 of 6 runs, harness arms in 0 of</a:t>
+            </a:r>
+          </a:p>
+          <a:p>
+            <a:r>
+              <a:t>6. On F2 the harness arms also stayed inside the allowed paths (0 of 9), but demo-2 has no scope</a:t>
+            </a:r>
+          </a:p>
+          <a:p>
+            <a:r>
+              <a:t>layer, so that is not the scope layer's doing. Sandbox: no `sandbox_denied` event in any recorded</a:t>
+            </a:r>
+          </a:p>
+          <a:p>
+            <a:r>
+              <a:t>pilot A/B (checked on 2026-10-17 with `grep -l sandbox_denied .shipharness/runs/*/events.jsonl`),</a:t>
+            </a:r>
+          </a:p>
+          <a:p>
+            <a:r>
+              <a:t>and none in the quiet run.</a:t>
             </a:r>
           </a:p>
           <a:p/>
@@ -4499,7 +4683,7 @@
           </a:p>
           <a:p>
             <a:r>
-              <a:t>Source: course pilot runs 2-4 and class-profile round (A/B ids above).</a:t>
+              <a:t>Source: quiet run ab-20261017-114259-b64f54 (screen 3); course pilot runs 2-4 and class-profile round (A/B ids above).</a:t>
             </a:r>
           </a:p>
         </p:txBody>
@@ -4958,54 +5142,64 @@
           </a:p>
           <a:p>
             <a:r>
-              <a:t>are live at a time; the S4 replay starts in terminal B only after show-4 has finished.</a:t>
-            </a:r>
-          </a:p>
-          <a:p>
-            <a:r>
-              <a:t>The class profile is identical for both arms: effort low, Fast tier, 2 CPUs per container, early</a:t>
-            </a:r>
-          </a:p>
-          <a:p>
-            <a:r>
-              <a:t>primary verdict, five flakiness re-runs.</a:t>
+              <a:t>are live at a time. The class profile is identical for both arms: effort low, Fast tier, 2 CPUs per</a:t>
+            </a:r>
+          </a:p>
+          <a:p>
+            <a:r>
+              <a:t>container, early primary verdict, five flakiness re-runs. Final run cap $0.25 per arm.</a:t>
             </a:r>
           </a:p>
           <a:p/>
           <a:p>
             <a:r>
-              <a:t>Timing reference for show-4: in the class-profile round (A/B ab-20261017-090903-926c02, run alone),</a:t>
-            </a:r>
-          </a:p>
-          <a:p>
-            <a:r>
-              <a:t>the harness arm's primary verdict came 811 s after launch and its full verdict 927 s after launch; it</a:t>
-            </a:r>
-          </a:p>
-          <a:p>
-            <a:r>
-              <a:t>hit the agent time limit in the test phase.</a:t>
-            </a:r>
-          </a:p>
-          <a:p>
-            <a:r>
-              <a:t>[[CAPTURE: wall time of make show-4 on the class host, launch to the primary verdict and to the full verdict | how: make show-4]]</a:t>
+              <a:t>Timing reference for show-4: in the quiet run of `make show-4` (captured on 2026-10-17, run</a:t>
+            </a:r>
+          </a:p>
+          <a:p>
+            <a:r>
+              <a:t>ab-20261017-115138-c45d9d; your output will differ) the primary verdict came 9:19 after launch, the</a:t>
+            </a:r>
+          </a:p>
+          <a:p>
+            <a:r>
+              <a:t>full verdict 10:55 after launch, and the command took 11 min 6 s in all. It exited 2: the agent time</a:t>
+            </a:r>
+          </a:p>
+          <a:p>
+            <a:r>
+              <a:t>limit ended the test phase. In the class-profile round (A/B ab-20261017-090903-926c02, run alone)</a:t>
+            </a:r>
+          </a:p>
+          <a:p>
+            <a:r>
+              <a:t>the harness arm's primary verdict came 811 s and its full verdict 927 s after launch.</a:t>
             </a:r>
           </a:p>
           <a:p/>
           <a:p>
             <a:r>
-              <a:t>The final A/B must be finished by 3:40, when slide 64 opens the final block; with two features</a:t>
-            </a:r>
-          </a:p>
-          <a:p>
-            <a:r>
-              <a:t>`make final` runs them one after another.</a:t>
-            </a:r>
-          </a:p>
-          <a:p>
-            <a:r>
-              <a:t>[[CAPTURE: wall time of make final FEATURES=F5 on the class host, launch to each arm's primary verdict and full verdict | how: make final FEATURES=F5]]</a:t>
+              <a:t>Timing reference for the final: the quiet run of `make final FEATURES=F5` (captured on</a:t>
+            </a:r>
+          </a:p>
+          <a:p>
+            <a:r>
+              <a:t>2026-10-17, run ab-20261017-120323-c97138; your output will differ) took 12 min 47 s: bare arm</a:t>
+            </a:r>
+          </a:p>
+          <a:p>
+            <a:r>
+              <a:t>primary verdict 3:27 and full verdict 6:50 after launch, harness arm 9:48 and 12:32 (it hit the</a:t>
+            </a:r>
+          </a:p>
+          <a:p>
+            <a:r>
+              <a:t>agent time limit, exit 2). The final A/B must be finished by 3:40, when slide 64 opens the final</a:t>
+            </a:r>
+          </a:p>
+          <a:p>
+            <a:r>
+              <a:t>block; with two features `make final` runs them one after another.</a:t>
             </a:r>
           </a:p>
           <a:p/>
@@ -5736,17 +5930,7 @@
           </a:p>
           <a:p>
             <a:r>
-              <a:t>show-4 `Cost:` line and terminal C for the final (timing references in the notes of slide 51). Once</a:t>
-            </a:r>
-          </a:p>
-          <a:p>
-            <a:r>
-              <a:t>show-4 has finished, start the replay for slide 61 in terminal B:</a:t>
-            </a:r>
-          </a:p>
-          <a:p>
-            <a:r>
-              <a:t>`make replay RUN=ab-20261017-090903-926c02`.</a:t>
+              <a:t>show-4 `Cost:` line and terminal C for the final (timing references in the notes of slide 51).</a:t>
             </a:r>
           </a:p>
           <a:p/>
@@ -5930,7 +6114,12 @@
           <a:p/>
           <a:p>
             <a:r>
-              <a:t>`names = ...`, the build-phase branch, the clean-state check, and `passed = ...`.</a:t>
+              <a:t>`names = ...`, the build-phase branch, the start of the clean-state check, its failure line, and</a:t>
+            </a:r>
+          </a:p>
+          <a:p>
+            <a:r>
+              <a:t>`passed = ...`.</a:t>
             </a:r>
           </a:p>
           <a:p/>
@@ -6017,27 +6206,52 @@
           <a:p/>
           <a:p>
             <a:r>
-              <a:t>The replayed run: class-profile round, F4, A/B ab-20261017-090903-926c02. Bare arm: build session</a:t>
-            </a:r>
-          </a:p>
-          <a:p>
-            <a:r>
-              <a:t>ended with claim done after 30 turns, hidden tests 68 of 69, mutants killed 4 of 4, 16 shipped tests.</a:t>
-            </a:r>
-          </a:p>
-          <a:p>
-            <a:r>
-              <a:t>Harness arm: hidden 68 of 69, mutants 1 of 4; it wrote tests in the test phase for the first time in</a:t>
-            </a:r>
-          </a:p>
-          <a:p>
-            <a:r>
-              <a:t>any pilot run, and the test-phase filters ran each of its 6 tests 5 times. Say at the filter table:</a:t>
-            </a:r>
-          </a:p>
-          <a:p>
-            <a:r>
-              <a:t>"The referee-set mutants were never visible to the filters."</a:t>
+              <a:t>In the quiet run (captured on 2026-10-17, run ab-20261017-115138-c45d9d; your output will differ):</a:t>
+            </a:r>
+          </a:p>
+          <a:p>
+            <a:r>
+              <a:t>minute 1, turn 1.15 tried to patch app/services/errors.py and the scope layer blocked it ("outside</a:t>
+            </a:r>
+          </a:p>
+          <a:p>
+            <a:r>
+              <a:t>the allowed paths"); minute 3, turn 1.31 called `finish done` and the gate ran, every pill ✓</a:t>
+            </a:r>
+          </a:p>
+          <a:p>
+            <a:r>
+              <a:t>(visible tests, existing tests, R1-R7, board, clean state); the harness then set F4 `passes` with</a:t>
+            </a:r>
+          </a:p>
+          <a:p>
+            <a:r>
+              <a:t>its evidence and moved the exec plan to completed; minutes 4-8, the test phase: one new test file,</a:t>
+            </a:r>
+          </a:p>
+          <a:p>
+            <a:r>
+              <a:t>a failing `run_visible_tests`, the filters; minute 9, the agent time limit ended the run and screen 1</a:t>
+            </a:r>
+          </a:p>
+          <a:p>
+            <a:r>
+              <a:t>showed "primary verdict ready: FAIL" at 9:19; the full verdict came at 10:55. Screen 2's conflict</a:t>
+            </a:r>
+          </a:p>
+          <a:p>
+            <a:r>
+              <a:t>panel: "CONFLICT DETECTED: tab B got HTTP 409", and tab B read "This issue was changed by someone</a:t>
+            </a:r>
+          </a:p>
+          <a:p>
+            <a:r>
+              <a:t>else". Say at the filter table: "The referee-set mutants were never visible to the filters." The</a:t>
+            </a:r>
+          </a:p>
+          <a:p>
+            <a:r>
+              <a:t>image joins the harness panel of screen 1 with the conflict panel's banner and tab B.</a:t>
             </a:r>
           </a:p>
           <a:p/>
@@ -6048,7 +6262,7 @@
           </a:p>
           <a:p>
             <a:r>
-              <a:t>Source: README.md §11; Makefile `show-4`, `replay`.</a:t>
+              <a:t>Source: quiet run ab-20261017-115138-c45d9d (screens 1 and 2); README.md §11; Makefile `show-4`.</a:t>
             </a:r>
           </a:p>
         </p:txBody>
@@ -6124,6 +6338,37 @@
           <a:p/>
           <a:p>
             <a:r>
+              <a:t>The quiet run's arm line (captured on 2026-10-17, run ab-20261017-115138-c45d9d; your output will</a:t>
+            </a:r>
+          </a:p>
+          <a:p>
+            <a:r>
+              <a:t>differ): `harness ABORTED: timeout claim=done primary={"hidden_passed": 68, "mutants_killed": 0}</a:t>
+            </a:r>
+          </a:p>
+          <a:p>
+            <a:r>
+              <a:t>passed=False hidden 68/69 mutants 0/4 reviewer=reject cost=$0.0233`. Filter table: 4 proposed tests,</a:t>
+            </a:r>
+          </a:p>
+          <a:p>
+            <a:r>
+              <a:t>1 kept; two discarded by filter 3 (no new line coverage) and one by filter 2 ("failed on run 1 of 5:</a:t>
+            </a:r>
+          </a:p>
+          <a:p>
+            <a:r>
+              <a:t>assert 422 == 412"). Diff map: one ⊘ blocked file (app/services/errors.py), every shipped file inside</a:t>
+            </a:r>
+          </a:p>
+          <a:p>
+            <a:r>
+              <a:t>the allowed paths. This is a show run, so it is not part of the pilot counts below.</a:t>
+            </a:r>
+          </a:p>
+          <a:p/>
+          <a:p>
+            <a:r>
               <a:t>The 4 A/Bs: run 3 (ab-20261016-212252-aa1644, ab-20261016-214151-ca9841, ab-20261016-220010-c5b4bf),</a:t>
             </a:r>
           </a:p>
@@ -6134,22 +6379,27 @@
           </a:p>
           <a:p>
             <a:r>
-              <a:t>killed 4, 0, 3 of 4. On F4 in runs 2 and 3 the harness arm never called `finish`, so its verify gate</a:t>
-            </a:r>
-          </a:p>
-          <a:p>
-            <a:r>
-              <a:t>never ran; in two of the three run 3 A/Bs the agent time limit cut its test phase. F4 had no run 4 (pilot cap). Post hoc:</a:t>
-            </a:r>
-          </a:p>
-          <a:p>
-            <a:r>
-              <a:t>chosen after the results, descriptive; runs 2-4 and the live console check, 34 runs per arm.</a:t>
-            </a:r>
-          </a:p>
-          <a:p>
-            <a:r>
-              <a:t>[[CAPTURE: what make example-4 shows on each console screen, and its wall time | how: make example-4]]</a:t>
+              <a:t>killed 4, 0, 3 of 4. Class-profile round: both arms 68 of 69 hidden tests; mutants killed: bare 4,</a:t>
+            </a:r>
+          </a:p>
+          <a:p>
+            <a:r>
+              <a:t>harness 1. On F4 in runs 2 and 3 the harness arm never claimed done (0 of 6), so its verify gate never</a:t>
+            </a:r>
+          </a:p>
+          <a:p>
+            <a:r>
+              <a:t>ran; in two of the three run 3 A/Bs the agent time limit cut its test phase. F4 had no run 4 (pilot</a:t>
+            </a:r>
+          </a:p>
+          <a:p>
+            <a:r>
+              <a:t>cap). Post hoc (chosen after the results, descriptive; runs 2-4 and the live console check, 34 runs</a:t>
+            </a:r>
+          </a:p>
+          <a:p>
+            <a:r>
+              <a:t>per arm): no done claim came with failing hidden tests (0 of 19 bare, 0 of 10 harness).</a:t>
             </a:r>
           </a:p>
           <a:p/>
@@ -6160,7 +6410,7 @@
           </a:p>
           <a:p>
             <a:r>
-              <a:t>Source: course pilot runs 2-4 and class-profile round (A/B ids above).</a:t>
+              <a:t>Source: quiet run ab-20261017-115138-c45d9d (screen 3); course pilot runs 2-4 and class-profile round (A/B ids above).</a:t>
             </a:r>
           </a:p>
         </p:txBody>
@@ -6420,7 +6670,32 @@
           <a:p/>
           <a:p>
             <a:r>
-              <a:t>Both arms, side by side.</a:t>
+              <a:t>Both arms, side by side. Show tonight's final live; the picture is the quiet run of `make final</a:t>
+            </a:r>
+          </a:p>
+          <a:p>
+            <a:r>
+              <a:t>FEATURES=F5` (captured on 2026-10-17, run ab-20261017-120323-c97138; your output will differ): bare</a:t>
+            </a:r>
+          </a:p>
+          <a:p>
+            <a:r>
+              <a:t>arm completed and claimed done, primary verdict 3:27 and full verdict 6:50 after launch; harness arm</a:t>
+            </a:r>
+          </a:p>
+          <a:p>
+            <a:r>
+              <a:t>hit the agent time limit without a claim, 9:48 and 12:32; hidden tests 46 of 46 and mutants killed 2</a:t>
+            </a:r>
+          </a:p>
+          <a:p>
+            <a:r>
+              <a:t>of 3 in both arms; F5 has no primary measure, so read those counts. The harness arm's second turn</a:t>
+            </a:r>
+          </a:p>
+          <a:p>
+            <a:r>
+              <a:t>read session-handoff.md.</a:t>
             </a:r>
           </a:p>
           <a:p/>
@@ -6512,7 +6787,12 @@
           </a:p>
           <a:p>
             <a:r>
-              <a:t>board showed "✓ only own-org cards, no duplicates".</a:t>
+              <a:t>board showed "✓ only own-org cards, no duplicates", and so did both boards of the quiet final run</a:t>
+            </a:r>
+          </a:p>
+          <a:p>
+            <a:r>
+              <a:t>(captured on 2026-10-17, run ab-20261017-120323-c97138; your output will differ).</a:t>
             </a:r>
           </a:p>
           <a:p/>
@@ -6824,7 +7104,12 @@
           <a:p/>
           <a:p>
             <a:r>
-              <a:t>Learner budgets are course design.</a:t>
+              <a:t>Learner budgets are course design; the figures are the live-step bounds in README.md §12 and each</a:t>
+            </a:r>
+          </a:p>
+          <a:p>
+            <a:r>
+              <a:t>assignment's "Cost and trace budget".</a:t>
             </a:r>
           </a:p>
           <a:p/>
@@ -7381,28 +7666,33 @@
           </a:p>
           <a:p>
             <a:r>
-              <a:t>instead, plus one real run replayed and one constructed example.</a:t>
+              <a:t>instead, live.</a:t>
             </a:r>
           </a:p>
           <a:p/>
           <a:p>
             <a:r>
-              <a:t>Timing reference: in the class-profile round (2026-10-17, A/B ab-20261017-084558-0356a0, class</a:t>
-            </a:r>
-          </a:p>
-          <a:p>
-            <a:r>
-              <a:t>profile: effort low, Fast tier, 2 CPUs per container, early primary verdict), the harness arm's</a:t>
-            </a:r>
-          </a:p>
-          <a:p>
-            <a:r>
-              <a:t>primary verdict came 114 s after launch and its full verdict 324 s after launch.</a:t>
-            </a:r>
-          </a:p>
-          <a:p>
-            <a:r>
-              <a:t>[[CAPTURE: wall time of make show-1 on the class host, launch to the primary verdict and to the full verdict | how: make show-1]]</a:t>
+              <a:t>Timing reference: in the quiet run of `make show-1` (captured on 2026-10-17, run</a:t>
+            </a:r>
+          </a:p>
+          <a:p>
+            <a:r>
+              <a:t>ab-20261017-112101-c5d839; your output will differ) the primary verdict came 4:11 after launch, the</a:t>
+            </a:r>
+          </a:p>
+          <a:p>
+            <a:r>
+              <a:t>full verdict 10:00 after launch, and the command took 10 min 14 s in all (exit 0). In the</a:t>
+            </a:r>
+          </a:p>
+          <a:p>
+            <a:r>
+              <a:t>class-profile round (A/B ab-20261017-084558-0356a0) the harness arm's primary verdict came 114 s and</a:t>
+            </a:r>
+          </a:p>
+          <a:p>
+            <a:r>
+              <a:t>its full verdict 324 s after launch.</a:t>
             </a:r>
           </a:p>
           <a:p/>
@@ -11087,7 +11377,7 @@
                 </a:solidFill>
                 <a:latin typeface="Calibri"/>
               </a:rPr>
-              <a:t>Read the S1 result: R1 and R3 failures with and without the instructions layer</a:t>
+              <a:t>Read the S1 result: new R1 violations per run, bare arm against harness arm</a:t>
             </a:r>
           </a:p>
           <a:p>
@@ -15124,7 +15414,7 @@
                 </a:solidFill>
                 <a:latin typeface="Calibri"/>
               </a:rPr>
-              <a:t>Demo block: harness in action, and a real run replayed</a:t>
+              <a:t>Demo block: what to watch</a:t>
             </a:r>
           </a:p>
         </p:txBody>
@@ -15138,7 +15428,7 @@
         <p:spPr>
           <a:xfrm>
             <a:off x="533400" y="1219200"/>
-            <a:ext cx="11125200" cy="4705350"/>
+            <a:ext cx="11125200" cy="2229707"/>
           </a:xfrm>
           <a:prstGeom prst="rect">
             <a:avLst/>
@@ -15153,11 +15443,11 @@
           <a:p>
             <a:pPr algn="l">
               <a:spcAft>
-                <a:spcPts val="945"/>
+                <a:spcPts val="860"/>
               </a:spcAft>
             </a:pPr>
             <a:r>
-              <a:rPr sz="2100" b="0">
+              <a:rPr sz="1912" b="0">
                 <a:solidFill>
                   <a:srgbClr val="111820"/>
                 </a:solidFill>
@@ -15166,32 +15456,23 @@
               <a:t>•  </a:t>
             </a:r>
             <a:r>
-              <a:rPr sz="2100" b="0">
-                <a:solidFill>
-                  <a:srgbClr val="111820"/>
-                </a:solidFill>
-                <a:latin typeface="Consolas"/>
-              </a:rPr>
-              <a:t>make show-1</a:t>
-            </a:r>
-            <a:r>
-              <a:rPr sz="2100" b="0">
-                <a:solidFill>
-                  <a:srgbClr val="111820"/>
-                </a:solidFill>
-                <a:latin typeface="Calibri"/>
-              </a:rPr>
-              <a:t>, finished: screen 1 shows "primary verdict ready", then the full verdict</a:t>
+              <a:rPr sz="1912" b="0">
+                <a:solidFill>
+                  <a:srgbClr val="111820"/>
+                </a:solidFill>
+                <a:latin typeface="Calibri"/>
+              </a:rPr>
+              <a:t>Screen 1: build turns, test phase, "Agent said done", "primary verdict ready", full verdict</a:t>
             </a:r>
           </a:p>
           <a:p>
             <a:pPr algn="l">
               <a:spcAft>
-                <a:spcPts val="945"/>
+                <a:spcPts val="860"/>
               </a:spcAft>
             </a:pPr>
             <a:r>
-              <a:rPr sz="2100" b="0">
+              <a:rPr sz="1912" b="0">
                 <a:solidFill>
                   <a:srgbClr val="111820"/>
                 </a:solidFill>
@@ -15200,23 +15481,23 @@
               <a:t>•  </a:t>
             </a:r>
             <a:r>
-              <a:rPr sz="2100" b="0">
-                <a:solidFill>
-                  <a:srgbClr val="111820"/>
-                </a:solidFill>
-                <a:latin typeface="Calibri"/>
-              </a:rPr>
-              <a:t>Screen 1: the map read first, then the documents the ticket needs; screen 3: files read by category</a:t>
+              <a:rPr sz="1912" b="0">
+                <a:solidFill>
+                  <a:srgbClr val="111820"/>
+                </a:solidFill>
+                <a:latin typeface="Calibri"/>
+              </a:rPr>
+              <a:t>Screen 3: files read and the diff map; screen 2: the board ("✓ only own-org cards"); screen 5: trace links</a:t>
             </a:r>
           </a:p>
           <a:p>
             <a:pPr algn="l">
               <a:spcAft>
-                <a:spcPts val="945"/>
+                <a:spcPts val="860"/>
               </a:spcAft>
             </a:pPr>
             <a:r>
-              <a:rPr sz="2100" b="0">
+              <a:rPr sz="1912" b="0">
                 <a:solidFill>
                   <a:srgbClr val="111820"/>
                 </a:solidFill>
@@ -15225,63 +15506,44 @@
               <a:t>•  </a:t>
             </a:r>
             <a:r>
-              <a:rPr sz="2100" b="0">
-                <a:solidFill>
-                  <a:srgbClr val="111820"/>
-                </a:solidFill>
-                <a:latin typeface="Calibri"/>
-              </a:rPr>
-              <a:t>Real run, replayed: </a:t>
-            </a:r>
-            <a:r>
-              <a:rPr sz="2100" b="0">
-                <a:solidFill>
-                  <a:srgbClr val="111820"/>
-                </a:solidFill>
-                <a:latin typeface="Consolas"/>
-              </a:rPr>
-              <a:t>make replay RUN=ab-20261016-212252-aa1644</a:t>
-            </a:r>
-            <a:r>
-              <a:rPr sz="2100" b="0">
-                <a:solidFill>
-                  <a:srgbClr val="111820"/>
-                </a:solidFill>
-                <a:latin typeface="Calibri"/>
-              </a:rPr>
-              <a:t> (pilot run 3, F4)</a:t>
-            </a:r>
-          </a:p>
-          <a:p>
-            <a:pPr algn="l">
-              <a:spcAft>
-                <a:spcPts val="945"/>
-              </a:spcAft>
-            </a:pPr>
-            <a:r>
-              <a:rPr sz="2100" b="0">
-                <a:solidFill>
-                  <a:srgbClr val="111820"/>
-                </a:solidFill>
-                <a:latin typeface="Calibri"/>
-              </a:rPr>
-              <a:t>•  </a:t>
-            </a:r>
-            <a:r>
-              <a:rPr sz="2100" b="0">
-                <a:solidFill>
-                  <a:srgbClr val="111820"/>
-                </a:solidFill>
-                <a:latin typeface="Calibri"/>
-              </a:rPr>
-              <a:t>In that run the harness arm's change added 3 new R1 violations, and the referee's R1 check listed them</a:t>
-            </a:r>
-          </a:p>
-        </p:txBody>
-      </p:sp>
-      <p:sp>
-        <p:nvSpPr>
-          <p:cNvPr id="9" name="Rectangle 8"/>
+              <a:rPr sz="1912" b="0">
+                <a:solidFill>
+                  <a:srgbClr val="111820"/>
+                </a:solidFill>
+                <a:latin typeface="Calibri"/>
+              </a:rPr>
+              <a:t>Console screens 1 and 2 (show-1), captured on 2026-10-17, run ab-20261017-112101-c5d839; your output will differ</a:t>
+            </a:r>
+          </a:p>
+        </p:txBody>
+      </p:sp>
+      <p:pic>
+        <p:nvPicPr>
+          <p:cNvPr id="9" name="Picture 8" descr="s1-watch.png"/>
+          <p:cNvPicPr>
+            <a:picLocks noChangeAspect="1"/>
+          </p:cNvPicPr>
+          <p:nvPr/>
+        </p:nvPicPr>
+        <p:blipFill>
+          <a:blip r:embed="rId2"/>
+          <a:stretch>
+            <a:fillRect/>
+          </a:stretch>
+        </p:blipFill>
+        <p:spPr>
+          <a:xfrm>
+            <a:off x="2911123" y="3544157"/>
+            <a:ext cx="6369755" cy="2380393"/>
+          </a:xfrm>
+          <a:prstGeom prst="rect">
+            <a:avLst/>
+          </a:prstGeom>
+        </p:spPr>
+      </p:pic>
+      <p:sp>
+        <p:nvSpPr>
+          <p:cNvPr id="10" name="Rectangle 9"/>
           <p:cNvSpPr/>
           <p:nvPr/>
         </p:nvSpPr>
@@ -15327,7 +15589,7 @@
       </p:sp>
       <p:sp>
         <p:nvSpPr>
-          <p:cNvPr id="10" name="TextBox 9"/>
+          <p:cNvPr id="11" name="TextBox 10"/>
           <p:cNvSpPr txBox="1"/>
           <p:nvPr/>
         </p:nvSpPr>
@@ -15992,7 +16254,7 @@
         <p:spPr>
           <a:xfrm>
             <a:off x="533400" y="628650"/>
-            <a:ext cx="11125200" cy="933450"/>
+            <a:ext cx="11125200" cy="495300"/>
           </a:xfrm>
           <a:prstGeom prst="rect">
             <a:avLst/>
@@ -16013,7 +16275,7 @@
                 </a:solidFill>
                 <a:latin typeface="Calibri"/>
               </a:rPr>
-              <a:t>Demo block: a constructed example, and what the pilot measured</a:t>
+              <a:t>Demo block: reading the result</a:t>
             </a:r>
           </a:p>
         </p:txBody>
@@ -16026,8 +16288,8 @@
         </p:nvSpPr>
         <p:spPr>
           <a:xfrm>
-            <a:off x="533400" y="1657350"/>
-            <a:ext cx="11125200" cy="4743450"/>
+            <a:off x="533400" y="1219200"/>
+            <a:ext cx="11125200" cy="3094387"/>
           </a:xfrm>
           <a:prstGeom prst="rect">
             <a:avLst/>
@@ -16042,11 +16304,11 @@
           <a:p>
             <a:pPr algn="l">
               <a:spcAft>
-                <a:spcPts val="945"/>
+                <a:spcPts val="860"/>
               </a:spcAft>
             </a:pPr>
             <a:r>
-              <a:rPr sz="2100" b="0">
+              <a:rPr sz="1912" b="0">
                 <a:solidFill>
                   <a:srgbClr val="111820"/>
                 </a:solidFill>
@@ -16055,41 +16317,23 @@
               <a:t>•  </a:t>
             </a:r>
             <a:r>
-              <a:rPr sz="2100" b="0">
-                <a:solidFill>
-                  <a:srgbClr val="111820"/>
-                </a:solidFill>
-                <a:latin typeface="Calibri"/>
-              </a:rPr>
-              <a:t>Constructed example: </a:t>
-            </a:r>
-            <a:r>
-              <a:rPr sz="2100" b="0">
-                <a:solidFill>
-                  <a:srgbClr val="111820"/>
-                </a:solidFill>
-                <a:latin typeface="Consolas"/>
-              </a:rPr>
-              <a:t>make example-1</a:t>
-            </a:r>
-            <a:r>
-              <a:rPr sz="2100" b="0">
-                <a:solidFill>
-                  <a:srgbClr val="111820"/>
-                </a:solidFill>
-                <a:latin typeface="Calibri"/>
-              </a:rPr>
-              <a:t>, scripted, no model; CONSTRUCTED EXAMPLE on every screen</a:t>
+              <a:rPr sz="1912" b="0">
+                <a:solidFill>
+                  <a:srgbClr val="111820"/>
+                </a:solidFill>
+                <a:latin typeface="Calibri"/>
+              </a:rPr>
+              <a:t>show-1 in the quiet run: 0 new R1 violations (passes), hidden tests 52 of 52, mutants killed 2 of 4</a:t>
             </a:r>
           </a:p>
           <a:p>
             <a:pPr algn="l">
               <a:spcAft>
-                <a:spcPts val="945"/>
+                <a:spcPts val="860"/>
               </a:spcAft>
             </a:pPr>
             <a:r>
-              <a:rPr sz="2100" b="0">
+              <a:rPr sz="1912" b="0">
                 <a:solidFill>
                   <a:srgbClr val="111820"/>
                 </a:solidFill>
@@ -16098,23 +16342,23 @@
               <a:t>•  </a:t>
             </a:r>
             <a:r>
-              <a:rPr sz="2100" b="0">
-                <a:solidFill>
-                  <a:srgbClr val="111820"/>
-                </a:solidFill>
-                <a:latin typeface="Calibri"/>
-              </a:rPr>
-              <a:t>It shows the ⚠ other-org marks on a board, which no pilot arm produced</a:t>
+              <a:rPr sz="1912" b="0">
+                <a:solidFill>
+                  <a:srgbClr val="111820"/>
+                </a:solidFill>
+                <a:latin typeface="Calibri"/>
+              </a:rPr>
+              <a:t>One harness arm on one run shows the layer ran, not that it helped: that takes the A/B</a:t>
             </a:r>
           </a:p>
           <a:p>
             <a:pPr algn="l">
               <a:spcAft>
-                <a:spcPts val="945"/>
+                <a:spcPts val="860"/>
               </a:spcAft>
             </a:pPr>
             <a:r>
-              <a:rPr sz="2100" b="0">
+              <a:rPr sz="1912" b="0">
                 <a:solidFill>
                   <a:srgbClr val="111820"/>
                 </a:solidFill>
@@ -16123,7 +16367,7 @@
               <a:t>•  </a:t>
             </a:r>
             <a:r>
-              <a:rPr sz="2100" b="0">
+              <a:rPr sz="1912" b="0">
                 <a:solidFill>
                   <a:srgbClr val="111820"/>
                 </a:solidFill>
@@ -16135,11 +16379,11 @@
           <a:p>
             <a:pPr algn="l">
               <a:spcAft>
-                <a:spcPts val="945"/>
+                <a:spcPts val="860"/>
               </a:spcAft>
             </a:pPr>
             <a:r>
-              <a:rPr sz="2100" b="0">
+              <a:rPr sz="1912" b="0">
                 <a:solidFill>
                   <a:srgbClr val="111820"/>
                 </a:solidFill>
@@ -16148,7 +16392,7 @@
               <a:t>•  </a:t>
             </a:r>
             <a:r>
-              <a:rPr sz="2100" b="0">
+              <a:rPr sz="1912" b="0">
                 <a:solidFill>
                   <a:srgbClr val="111820"/>
                 </a:solidFill>
@@ -16160,11 +16404,11 @@
           <a:p>
             <a:pPr algn="l">
               <a:spcAft>
-                <a:spcPts val="945"/>
+                <a:spcPts val="860"/>
               </a:spcAft>
             </a:pPr>
             <a:r>
-              <a:rPr sz="2100" b="0">
+              <a:rPr sz="1912" b="0">
                 <a:solidFill>
                   <a:srgbClr val="111820"/>
                 </a:solidFill>
@@ -16173,42 +16417,41 @@
               <a:t>•  </a:t>
             </a:r>
             <a:r>
-              <a:rPr sz="2100" b="0">
-                <a:solidFill>
-                  <a:srgbClr val="111820"/>
-                </a:solidFill>
-                <a:latin typeface="Calibri"/>
-              </a:rPr>
-              <a:t>Why: in run 2 every bare arm opened the handbook with its third tool call; no arm copied the legacy handler into a leak</a:t>
-            </a:r>
-          </a:p>
-          <a:p>
-            <a:pPr algn="l">
-              <a:spcAft>
-                <a:spcPts val="945"/>
-              </a:spcAft>
-            </a:pPr>
-            <a:r>
-              <a:rPr sz="2100" b="0">
-                <a:solidFill>
-                  <a:srgbClr val="111820"/>
-                </a:solidFill>
-                <a:latin typeface="Calibri"/>
-              </a:rPr>
-              <a:t>•  </a:t>
-            </a:r>
-            <a:r>
-              <a:rPr sz="2100" b="0">
-                <a:solidFill>
-                  <a:srgbClr val="111820"/>
-                </a:solidFill>
-                <a:latin typeface="Calibri"/>
-              </a:rPr>
-              <a:t>Post hoc, descriptive (10 runs per arm): done claimed by harness 5, bare 9; median cost $0.0122 against $0.0103</a:t>
-            </a:r>
-          </a:p>
-        </p:txBody>
-      </p:sp>
+              <a:rPr sz="1912" b="0">
+                <a:solidFill>
+                  <a:srgbClr val="111820"/>
+                </a:solidFill>
+                <a:latin typeface="Calibri"/>
+              </a:rPr>
+              <a:t>Console screen 3 (show-1), captured on 2026-10-17, run ab-20261017-112101-c5d839; your output will differ</a:t>
+            </a:r>
+          </a:p>
+        </p:txBody>
+      </p:sp>
+      <p:pic>
+        <p:nvPicPr>
+          <p:cNvPr id="9" name="Picture 8" descr="s1-result.png"/>
+          <p:cNvPicPr>
+            <a:picLocks noChangeAspect="1"/>
+          </p:cNvPicPr>
+          <p:nvPr/>
+        </p:nvPicPr>
+        <p:blipFill>
+          <a:blip r:embed="rId2"/>
+          <a:stretch>
+            <a:fillRect/>
+          </a:stretch>
+        </p:blipFill>
+        <p:spPr>
+          <a:xfrm>
+            <a:off x="2368834" y="4408837"/>
+            <a:ext cx="7454332" cy="1991963"/>
+          </a:xfrm>
+          <a:prstGeom prst="rect">
+            <a:avLst/>
+          </a:prstGeom>
+        </p:spPr>
+      </p:pic>
     </p:spTree>
   </p:cSld>
   <p:clrMapOvr>
@@ -17292,7 +17535,7 @@
         <p:spPr>
           <a:xfrm>
             <a:off x="533400" y="1219200"/>
-            <a:ext cx="11125200" cy="5181600"/>
+            <a:ext cx="11125200" cy="2923032"/>
           </a:xfrm>
           <a:prstGeom prst="rect">
             <a:avLst/>
@@ -17424,6 +17667,30 @@
           </a:p>
         </p:txBody>
       </p:sp>
+      <p:pic>
+        <p:nvPicPr>
+          <p:cNvPr id="9" name="Picture 8" descr="2c0335426df628a5.png"/>
+          <p:cNvPicPr>
+            <a:picLocks noChangeAspect="1"/>
+          </p:cNvPicPr>
+          <p:nvPr/>
+        </p:nvPicPr>
+        <p:blipFill>
+          <a:blip r:embed="rId2"/>
+          <a:stretch>
+            <a:fillRect/>
+          </a:stretch>
+        </p:blipFill>
+        <p:spPr>
+          <a:xfrm>
+            <a:off x="533400" y="4989485"/>
+            <a:ext cx="11125200" cy="659312"/>
+          </a:xfrm>
+          <a:prstGeom prst="rect">
+            <a:avLst/>
+          </a:prstGeom>
+        </p:spPr>
+      </p:pic>
     </p:spTree>
   </p:cSld>
   <p:clrMapOvr>
@@ -20494,7 +20761,7 @@
         <p:spPr>
           <a:xfrm>
             <a:off x="533400" y="1219200"/>
-            <a:ext cx="11125200" cy="949452"/>
+            <a:ext cx="11125200" cy="1424178"/>
           </a:xfrm>
           <a:prstGeom prst="rect">
             <a:avLst/>
@@ -20565,6 +20832,31 @@
               <a:t>The neutral resume sentence comes first, the same for both arms</a:t>
             </a:r>
           </a:p>
+          <a:p>
+            <a:pPr algn="l">
+              <a:spcAft>
+                <a:spcPts val="945"/>
+              </a:spcAft>
+            </a:pPr>
+            <a:r>
+              <a:rPr sz="2100" b="0">
+                <a:solidFill>
+                  <a:srgbClr val="111820"/>
+                </a:solidFill>
+                <a:latin typeface="Calibri"/>
+              </a:rPr>
+              <a:t>•  </a:t>
+            </a:r>
+            <a:r>
+              <a:rPr sz="2100" b="0">
+                <a:solidFill>
+                  <a:srgbClr val="111820"/>
+                </a:solidFill>
+                <a:latin typeface="Calibri"/>
+              </a:rPr>
+              <a:t>A test-phase session starts with the feature's tests</a:t>
+            </a:r>
+          </a:p>
         </p:txBody>
       </p:sp>
       <p:sp>
@@ -20575,7 +20867,7 @@
         </p:nvSpPr>
         <p:spPr>
           <a:xfrm>
-            <a:off x="533400" y="2263902"/>
+            <a:off x="533400" y="2738628"/>
             <a:ext cx="11125200" cy="2548318"/>
           </a:xfrm>
           <a:prstGeom prst="rect">
@@ -20621,7 +20913,7 @@
         </p:nvSpPr>
         <p:spPr>
           <a:xfrm>
-            <a:off x="533400" y="2263902"/>
+            <a:off x="533400" y="2738628"/>
             <a:ext cx="57150" cy="2548318"/>
           </a:xfrm>
           <a:prstGeom prst="rect">
@@ -20665,7 +20957,7 @@
         </p:nvSpPr>
         <p:spPr>
           <a:xfrm>
-            <a:off x="704850" y="2359152"/>
+            <a:off x="704850" y="2833878"/>
             <a:ext cx="10858500" cy="2395918"/>
           </a:xfrm>
           <a:prstGeom prst="rect">
@@ -20796,7 +21088,7 @@
         </p:nvSpPr>
         <p:spPr>
           <a:xfrm>
-            <a:off x="533400" y="4831270"/>
+            <a:off x="533400" y="5305996"/>
             <a:ext cx="11125200" cy="209550"/>
           </a:xfrm>
           <a:prstGeom prst="rect">
@@ -21672,7 +21964,7 @@
                 </a:solidFill>
                 <a:latin typeface="Calibri"/>
               </a:rPr>
-              <a:t>Demo block: harness in action, and a real run replayed</a:t>
+              <a:t>Demo block: what to watch</a:t>
             </a:r>
           </a:p>
         </p:txBody>
@@ -21686,7 +21978,7 @@
         <p:spPr>
           <a:xfrm>
             <a:off x="533400" y="1219200"/>
-            <a:ext cx="11125200" cy="4705350"/>
+            <a:ext cx="5015023" cy="4705350"/>
           </a:xfrm>
           <a:prstGeom prst="rect">
             <a:avLst/>
@@ -21701,11 +21993,11 @@
           <a:p>
             <a:pPr algn="l">
               <a:spcAft>
-                <a:spcPts val="945"/>
+                <a:spcPts val="918"/>
               </a:spcAft>
             </a:pPr>
             <a:r>
-              <a:rPr sz="2100" b="0">
+              <a:rPr sz="2039" b="0">
                 <a:solidFill>
                   <a:srgbClr val="111820"/>
                 </a:solidFill>
@@ -21714,32 +22006,23 @@
               <a:t>•  </a:t>
             </a:r>
             <a:r>
-              <a:rPr sz="2100" b="0">
-                <a:solidFill>
-                  <a:srgbClr val="111820"/>
-                </a:solidFill>
-                <a:latin typeface="Consolas"/>
-              </a:rPr>
-              <a:t>make show-2</a:t>
-            </a:r>
-            <a:r>
-              <a:rPr sz="2100" b="0">
-                <a:solidFill>
-                  <a:srgbClr val="111820"/>
-                </a:solidFill>
-                <a:latin typeface="Calibri"/>
-              </a:rPr>
-              <a:t>, finished: screen 1 shows the session stop, the handoff, and the resume</a:t>
+              <a:rPr sz="2039" b="0">
+                <a:solidFill>
+                  <a:srgbClr val="111820"/>
+                </a:solidFill>
+                <a:latin typeface="Calibri"/>
+              </a:rPr>
+              <a:t>Screen 1: "■ Session 1 stopped" with the handoff file, then "▶ Session 2 resumed" with an empty context</a:t>
             </a:r>
           </a:p>
           <a:p>
             <a:pPr algn="l">
               <a:spcAft>
-                <a:spcPts val="945"/>
+                <a:spcPts val="918"/>
               </a:spcAft>
             </a:pPr>
             <a:r>
-              <a:rPr sz="2100" b="0">
+              <a:rPr sz="2039" b="0">
                 <a:solidFill>
                   <a:srgbClr val="111820"/>
                 </a:solidFill>
@@ -21748,23 +22031,41 @@
               <a:t>•  </a:t>
             </a:r>
             <a:r>
-              <a:rPr sz="2100" b="0">
-                <a:solidFill>
-                  <a:srgbClr val="111820"/>
-                </a:solidFill>
-                <a:latin typeface="Calibri"/>
-              </a:rPr>
-              <a:t>Screen 3: state files read at the start of session 2; screen 5: the trace links</a:t>
+              <a:rPr sz="2039" b="0">
+                <a:solidFill>
+                  <a:srgbClr val="111820"/>
+                </a:solidFill>
+                <a:latin typeface="Calibri"/>
+              </a:rPr>
+              <a:t>Session 2's first turn: </a:t>
+            </a:r>
+            <a:r>
+              <a:rPr sz="2039" b="0">
+                <a:solidFill>
+                  <a:srgbClr val="111820"/>
+                </a:solidFill>
+                <a:latin typeface="Consolas"/>
+              </a:rPr>
+              <a:t>pwd; git log; cat progress.md</a:t>
+            </a:r>
+            <a:r>
+              <a:rPr sz="2039" b="0">
+                <a:solidFill>
+                  <a:srgbClr val="111820"/>
+                </a:solidFill>
+                <a:latin typeface="Calibri"/>
+              </a:rPr>
+              <a:t>, A2's getting up to speed routine</a:t>
             </a:r>
           </a:p>
           <a:p>
             <a:pPr algn="l">
               <a:spcAft>
-                <a:spcPts val="945"/>
+                <a:spcPts val="918"/>
               </a:spcAft>
             </a:pPr>
             <a:r>
-              <a:rPr sz="2100" b="0">
+              <a:rPr sz="2039" b="0">
                 <a:solidFill>
                   <a:srgbClr val="111820"/>
                 </a:solidFill>
@@ -21773,41 +22074,23 @@
               <a:t>•  </a:t>
             </a:r>
             <a:r>
-              <a:rPr sz="2100" b="0">
-                <a:solidFill>
-                  <a:srgbClr val="111820"/>
-                </a:solidFill>
-                <a:latin typeface="Calibri"/>
-              </a:rPr>
-              <a:t>Real run, replayed: </a:t>
-            </a:r>
-            <a:r>
-              <a:rPr sz="2100" b="0">
-                <a:solidFill>
-                  <a:srgbClr val="111820"/>
-                </a:solidFill>
-                <a:latin typeface="Consolas"/>
-              </a:rPr>
-              <a:t>make replay RUN=ab-20261016-213317-9a0ec1</a:t>
-            </a:r>
-            <a:r>
-              <a:rPr sz="2100" b="0">
-                <a:solidFill>
-                  <a:srgbClr val="111820"/>
-                </a:solidFill>
-                <a:latin typeface="Calibri"/>
-              </a:rPr>
-              <a:t> (pilot run 3, F2)</a:t>
+              <a:rPr sz="2039" b="0">
+                <a:solidFill>
+                  <a:srgbClr val="111820"/>
+                </a:solidFill>
+                <a:latin typeface="Calibri"/>
+              </a:rPr>
+              <a:t>Screen 3: "Sessions", the turns and how each session ended; screen 5: the trace links</a:t>
             </a:r>
           </a:p>
           <a:p>
             <a:pPr algn="l">
               <a:spcAft>
-                <a:spcPts val="945"/>
+                <a:spcPts val="918"/>
               </a:spcAft>
             </a:pPr>
             <a:r>
-              <a:rPr sz="2100" b="0">
+              <a:rPr sz="2039" b="0">
                 <a:solidFill>
                   <a:srgbClr val="111820"/>
                 </a:solidFill>
@@ -21816,63 +22099,44 @@
               <a:t>•  </a:t>
             </a:r>
             <a:r>
-              <a:rPr sz="2100" b="0">
-                <a:solidFill>
-                  <a:srgbClr val="111820"/>
-                </a:solidFill>
-                <a:latin typeface="Calibri"/>
-              </a:rPr>
-              <a:t>Its harness arm called </a:t>
-            </a:r>
-            <a:r>
-              <a:rPr sz="2100" b="0">
-                <a:solidFill>
-                  <a:srgbClr val="111820"/>
-                </a:solidFill>
-                <a:latin typeface="Consolas"/>
-              </a:rPr>
-              <a:t>finish(claim="not_done")</a:t>
-            </a:r>
-            <a:r>
-              <a:rPr sz="2100" b="0">
-                <a:solidFill>
-                  <a:srgbClr val="111820"/>
-                </a:solidFill>
-                <a:latin typeface="Calibri"/>
-              </a:rPr>
-              <a:t> after session 1; the build phase ended, session 2 never ran</a:t>
-            </a:r>
-          </a:p>
-          <a:p>
-            <a:pPr algn="l">
-              <a:spcAft>
-                <a:spcPts val="945"/>
-              </a:spcAft>
-            </a:pPr>
-            <a:r>
-              <a:rPr sz="2100" b="0">
-                <a:solidFill>
-                  <a:srgbClr val="111820"/>
-                </a:solidFill>
-                <a:latin typeface="Calibri"/>
-              </a:rPr>
-              <a:t>•  </a:t>
-            </a:r>
-            <a:r>
-              <a:rPr sz="2100" b="0">
-                <a:solidFill>
-                  <a:srgbClr val="111820"/>
-                </a:solidFill>
-                <a:latin typeface="Calibri"/>
-              </a:rPr>
-              <a:t>The fix, for both arms: before the last build session, that call ends only the session</a:t>
-            </a:r>
-          </a:p>
-        </p:txBody>
-      </p:sp>
-      <p:sp>
-        <p:nvSpPr>
-          <p:cNvPr id="9" name="Rectangle 8"/>
+              <a:rPr sz="2039" b="0">
+                <a:solidFill>
+                  <a:srgbClr val="111820"/>
+                </a:solidFill>
+                <a:latin typeface="Calibri"/>
+              </a:rPr>
+              <a:t>Console screen 1 (show-2), captured on 2026-10-17, run ab-20261017-113213-fe89a3; your output will differ</a:t>
+            </a:r>
+          </a:p>
+        </p:txBody>
+      </p:sp>
+      <p:pic>
+        <p:nvPicPr>
+          <p:cNvPr id="9" name="Picture 8" descr="s2-watch.png"/>
+          <p:cNvPicPr>
+            <a:picLocks noChangeAspect="1"/>
+          </p:cNvPicPr>
+          <p:nvPr/>
+        </p:nvPicPr>
+        <p:blipFill>
+          <a:blip r:embed="rId2"/>
+          <a:stretch>
+            <a:fillRect/>
+          </a:stretch>
+        </p:blipFill>
+        <p:spPr>
+          <a:xfrm>
+            <a:off x="6061914" y="1219200"/>
+            <a:ext cx="5426095" cy="4705350"/>
+          </a:xfrm>
+          <a:prstGeom prst="rect">
+            <a:avLst/>
+          </a:prstGeom>
+        </p:spPr>
+      </p:pic>
+      <p:sp>
+        <p:nvSpPr>
+          <p:cNvPr id="10" name="Rectangle 9"/>
           <p:cNvSpPr/>
           <p:nvPr/>
         </p:nvSpPr>
@@ -21918,7 +22182,7 @@
       </p:sp>
       <p:sp>
         <p:nvSpPr>
-          <p:cNvPr id="10" name="TextBox 9"/>
+          <p:cNvPr id="11" name="TextBox 10"/>
           <p:cNvSpPr txBox="1"/>
           <p:nvPr/>
         </p:nvSpPr>
@@ -22189,7 +22453,7 @@
         <p:spPr>
           <a:xfrm>
             <a:off x="533400" y="628650"/>
-            <a:ext cx="11125200" cy="933450"/>
+            <a:ext cx="11125200" cy="495300"/>
           </a:xfrm>
           <a:prstGeom prst="rect">
             <a:avLst/>
@@ -22210,7 +22474,7 @@
                 </a:solidFill>
                 <a:latin typeface="Calibri"/>
               </a:rPr>
-              <a:t>Demo block: a constructed example, and what the pilot measured</a:t>
+              <a:t>Demo block: reading the result</a:t>
             </a:r>
           </a:p>
         </p:txBody>
@@ -22223,8 +22487,8 @@
         </p:nvSpPr>
         <p:spPr>
           <a:xfrm>
-            <a:off x="533400" y="1657350"/>
-            <a:ext cx="11125200" cy="4743450"/>
+            <a:off x="533400" y="1219200"/>
+            <a:ext cx="11125200" cy="3351848"/>
           </a:xfrm>
           <a:prstGeom prst="rect">
             <a:avLst/>
@@ -22239,11 +22503,11 @@
           <a:p>
             <a:pPr algn="l">
               <a:spcAft>
-                <a:spcPts val="945"/>
+                <a:spcPts val="776"/>
               </a:spcAft>
             </a:pPr>
             <a:r>
-              <a:rPr sz="2100" b="0">
+              <a:rPr sz="1725" b="0">
                 <a:solidFill>
                   <a:srgbClr val="111820"/>
                 </a:solidFill>
@@ -22252,41 +22516,23 @@
               <a:t>•  </a:t>
             </a:r>
             <a:r>
-              <a:rPr sz="2100" b="0">
-                <a:solidFill>
-                  <a:srgbClr val="111820"/>
-                </a:solidFill>
-                <a:latin typeface="Calibri"/>
-              </a:rPr>
-              <a:t>Constructed example: </a:t>
-            </a:r>
-            <a:r>
-              <a:rPr sz="2100" b="0">
-                <a:solidFill>
-                  <a:srgbClr val="111820"/>
-                </a:solidFill>
-                <a:latin typeface="Consolas"/>
-              </a:rPr>
-              <a:t>make example-2</a:t>
-            </a:r>
-            <a:r>
-              <a:rPr sz="2100" b="0">
-                <a:solidFill>
-                  <a:srgbClr val="111820"/>
-                </a:solidFill>
-                <a:latin typeface="Calibri"/>
-              </a:rPr>
-              <a:t>, scripted, no model; CONSTRUCTED EXAMPLE on every screen</a:t>
+              <a:rPr sz="1725" b="0">
+                <a:solidFill>
+                  <a:srgbClr val="111820"/>
+                </a:solidFill>
+                <a:latin typeface="Calibri"/>
+              </a:rPr>
+              <a:t>show-2 in the quiet run: no continuity failure (passes), hidden tests 56 of 56; session 2 hit the agent time limit</a:t>
             </a:r>
           </a:p>
           <a:p>
             <a:pPr algn="l">
               <a:spcAft>
-                <a:spcPts val="945"/>
+                <a:spcPts val="776"/>
               </a:spcAft>
             </a:pPr>
             <a:r>
-              <a:rPr sz="2100" b="0">
+              <a:rPr sz="1725" b="0">
                 <a:solidFill>
                   <a:srgbClr val="111820"/>
                 </a:solidFill>
@@ -22295,23 +22541,41 @@
               <a:t>•  </a:t>
             </a:r>
             <a:r>
-              <a:rPr sz="2100" b="0">
-                <a:solidFill>
-                  <a:srgbClr val="111820"/>
-                </a:solidFill>
-                <a:latin typeface="Calibri"/>
-              </a:rPr>
-              <a:t>Pilot, continuity failure fails: bare 0 of 7, harness 0 of 7 (poll answer: A); no measurable difference on this task with this model</a:t>
+              <a:rPr sz="1725" b="0">
+                <a:solidFill>
+                  <a:srgbClr val="111820"/>
+                </a:solidFill>
+                <a:latin typeface="Calibri"/>
+              </a:rPr>
+              <a:t>Screen 5's first wrong turn, a heuristic: turn 2.16 edited </a:t>
+            </a:r>
+            <a:r>
+              <a:rPr sz="1725" b="0">
+                <a:solidFill>
+                  <a:srgbClr val="111820"/>
+                </a:solidFill>
+                <a:latin typeface="Consolas"/>
+              </a:rPr>
+              <a:t>app/api/issues.py</a:t>
+            </a:r>
+            <a:r>
+              <a:rPr sz="1725" b="0">
+                <a:solidFill>
+                  <a:srgbClr val="111820"/>
+                </a:solidFill>
+                <a:latin typeface="Calibri"/>
+              </a:rPr>
+              <a:t>, outside the diff scope</a:t>
             </a:r>
           </a:p>
           <a:p>
             <a:pPr algn="l">
               <a:spcAft>
-                <a:spcPts val="945"/>
+                <a:spcPts val="776"/>
               </a:spcAft>
             </a:pPr>
             <a:r>
-              <a:rPr sz="2100" b="0">
+              <a:rPr sz="1725" b="0">
                 <a:solidFill>
                   <a:srgbClr val="111820"/>
                 </a:solidFill>
@@ -22320,23 +22584,23 @@
               <a:t>•  </a:t>
             </a:r>
             <a:r>
-              <a:rPr sz="2100" b="0">
-                <a:solidFill>
-                  <a:srgbClr val="111820"/>
-                </a:solidFill>
-                <a:latin typeface="Calibri"/>
-              </a:rPr>
-              <a:t>The measure cannot fail when session 1 leaves nothing to redo: in runs 3 and 4, 6 of 12 arms built nothing</a:t>
+              <a:rPr sz="1725" b="0">
+                <a:solidFill>
+                  <a:srgbClr val="111820"/>
+                </a:solidFill>
+                <a:latin typeface="Calibri"/>
+              </a:rPr>
+              <a:t>Pilot, continuity failure fails: bare 0 of 7, harness 0 of 7 (poll answer: A); no measurable difference on this task with this model</a:t>
             </a:r>
           </a:p>
           <a:p>
             <a:pPr algn="l">
               <a:spcAft>
-                <a:spcPts val="945"/>
+                <a:spcPts val="776"/>
               </a:spcAft>
             </a:pPr>
             <a:r>
-              <a:rPr sz="2100" b="0">
+              <a:rPr sz="1725" b="0">
                 <a:solidFill>
                   <a:srgbClr val="111820"/>
                 </a:solidFill>
@@ -22345,41 +22609,23 @@
               <a:t>•  </a:t>
             </a:r>
             <a:r>
-              <a:rPr sz="2100" b="0">
-                <a:solidFill>
-                  <a:srgbClr val="111820"/>
-                </a:solidFill>
-                <a:latin typeface="Calibri"/>
-              </a:rPr>
-              <a:t>The bare arm found its own state: in run 2 its session 2 ran </a:t>
-            </a:r>
-            <a:r>
-              <a:rPr sz="2100" b="0">
-                <a:solidFill>
-                  <a:srgbClr val="111820"/>
-                </a:solidFill>
-                <a:latin typeface="Consolas"/>
-              </a:rPr>
-              <a:t>git status</a:t>
-            </a:r>
-            <a:r>
-              <a:rPr sz="2100" b="0">
-                <a:solidFill>
-                  <a:srgbClr val="111820"/>
-                </a:solidFill>
-                <a:latin typeface="Calibri"/>
-              </a:rPr>
-              <a:t> in its fourth tool call</a:t>
+              <a:rPr sz="1725" b="0">
+                <a:solidFill>
+                  <a:srgbClr val="111820"/>
+                </a:solidFill>
+                <a:latin typeface="Calibri"/>
+              </a:rPr>
+              <a:t>The measure cannot fail when session 1 leaves nothing to redo: in runs 3 and 4, 6 of 12 arms built nothing</a:t>
             </a:r>
           </a:p>
           <a:p>
             <a:pPr algn="l">
               <a:spcAft>
-                <a:spcPts val="945"/>
+                <a:spcPts val="776"/>
               </a:spcAft>
             </a:pPr>
             <a:r>
-              <a:rPr sz="2100" b="0">
+              <a:rPr sz="1725" b="0">
                 <a:solidFill>
                   <a:srgbClr val="111820"/>
                 </a:solidFill>
@@ -22388,42 +22634,41 @@
               <a:t>•  </a:t>
             </a:r>
             <a:r>
-              <a:rPr sz="2100" b="0">
-                <a:solidFill>
-                  <a:srgbClr val="111820"/>
-                </a:solidFill>
-                <a:latin typeface="Calibri"/>
-              </a:rPr>
-              <a:t>Post hoc, descriptive (9 runs per arm): agent time limit hit, harness 4, bare 0; median wall 361 s against 232 s</a:t>
-            </a:r>
-          </a:p>
-          <a:p>
-            <a:pPr algn="l">
-              <a:spcAft>
-                <a:spcPts val="945"/>
-              </a:spcAft>
-            </a:pPr>
-            <a:r>
-              <a:rPr sz="2100" b="0">
-                <a:solidFill>
-                  <a:srgbClr val="111820"/>
-                </a:solidFill>
-                <a:latin typeface="Calibri"/>
-              </a:rPr>
-              <a:t>•  </a:t>
-            </a:r>
-            <a:r>
-              <a:rPr sz="2100" b="0">
-                <a:solidFill>
-                  <a:srgbClr val="111820"/>
-                </a:solidFill>
-                <a:latin typeface="Calibri"/>
-              </a:rPr>
-              <a:t>Class-profile round, with the fix: both arms built the feature, 56 of 56 hidden tests</a:t>
-            </a:r>
-          </a:p>
-        </p:txBody>
-      </p:sp>
+              <a:rPr sz="1725" b="0">
+                <a:solidFill>
+                  <a:srgbClr val="111820"/>
+                </a:solidFill>
+                <a:latin typeface="Calibri"/>
+              </a:rPr>
+              <a:t>Console screens 3 and 5 (show-2), captured on 2026-10-17, run ab-20261017-113213-fe89a3; your output will differ</a:t>
+            </a:r>
+          </a:p>
+        </p:txBody>
+      </p:sp>
+      <p:pic>
+        <p:nvPicPr>
+          <p:cNvPr id="9" name="Picture 8" descr="s2-result.png"/>
+          <p:cNvPicPr>
+            <a:picLocks noChangeAspect="1"/>
+          </p:cNvPicPr>
+          <p:nvPr/>
+        </p:nvPicPr>
+        <p:blipFill>
+          <a:blip r:embed="rId2"/>
+          <a:stretch>
+            <a:fillRect/>
+          </a:stretch>
+        </p:blipFill>
+        <p:spPr>
+          <a:xfrm>
+            <a:off x="2277812" y="4666298"/>
+            <a:ext cx="7636375" cy="1734503"/>
+          </a:xfrm>
+          <a:prstGeom prst="rect">
+            <a:avLst/>
+          </a:prstGeom>
+        </p:spPr>
+      </p:pic>
     </p:spTree>
   </p:cSld>
   <p:clrMapOvr>
@@ -23891,7 +24136,7 @@
         <p:spPr>
           <a:xfrm>
             <a:off x="533400" y="1219200"/>
-            <a:ext cx="11125200" cy="5181600"/>
+            <a:ext cx="11125200" cy="2923032"/>
           </a:xfrm>
           <a:prstGeom prst="rect">
             <a:avLst/>
@@ -23993,7 +24238,7 @@
                 </a:solidFill>
                 <a:latin typeface="Calibri"/>
               </a:rPr>
-              <a:t>Watch for: a blocked or reverted edit with its reason, and the sandbox policy at work</a:t>
+              <a:t>Watch for: a blocked or reverted edit with its reason, if the agent tries one, and the sandbox line</a:t>
             </a:r>
           </a:p>
           <a:p>
@@ -24021,33 +24266,32 @@
               <a:t>Build, then a test phase; allow lists from the task; shared middleware is off-limits</a:t>
             </a:r>
           </a:p>
-          <a:p>
-            <a:pPr algn="l">
-              <a:spcAft>
-                <a:spcPts val="945"/>
-              </a:spcAft>
-            </a:pPr>
-            <a:r>
-              <a:rPr sz="2100" b="0">
-                <a:solidFill>
-                  <a:srgbClr val="111820"/>
-                </a:solidFill>
-                <a:latin typeface="Calibri"/>
-              </a:rPr>
-              <a:t>•  </a:t>
-            </a:r>
-            <a:r>
-              <a:rPr sz="2100" b="0">
-                <a:solidFill>
-                  <a:srgbClr val="111820"/>
-                </a:solidFill>
-                <a:latin typeface="Calibri"/>
-              </a:rPr>
-              <a:t>Harness arm layers: instructions, state, scope</a:t>
-            </a:r>
-          </a:p>
-        </p:txBody>
-      </p:sp>
+        </p:txBody>
+      </p:sp>
+      <p:pic>
+        <p:nvPicPr>
+          <p:cNvPr id="9" name="Picture 8" descr="a03430f07b965ba6.png"/>
+          <p:cNvPicPr>
+            <a:picLocks noChangeAspect="1"/>
+          </p:cNvPicPr>
+          <p:nvPr/>
+        </p:nvPicPr>
+        <p:blipFill>
+          <a:blip r:embed="rId2"/>
+          <a:stretch>
+            <a:fillRect/>
+          </a:stretch>
+        </p:blipFill>
+        <p:spPr>
+          <a:xfrm>
+            <a:off x="533400" y="4768270"/>
+            <a:ext cx="11125200" cy="1101742"/>
+          </a:xfrm>
+          <a:prstGeom prst="rect">
+            <a:avLst/>
+          </a:prstGeom>
+        </p:spPr>
+      </p:pic>
     </p:spTree>
   </p:cSld>
   <p:clrMapOvr>
@@ -28571,7 +28815,7 @@
                 </a:solidFill>
                 <a:latin typeface="Calibri"/>
               </a:rPr>
-              <a:t>Demo block: harness in action, and a real run replayed</a:t>
+              <a:t>Demo block: what to watch</a:t>
             </a:r>
           </a:p>
         </p:txBody>
@@ -28585,7 +28829,7 @@
         <p:spPr>
           <a:xfrm>
             <a:off x="533400" y="1219200"/>
-            <a:ext cx="11125200" cy="4705350"/>
+            <a:ext cx="5015023" cy="4705350"/>
           </a:xfrm>
           <a:prstGeom prst="rect">
             <a:avLst/>
@@ -28617,18 +28861,36 @@
                 <a:solidFill>
                   <a:srgbClr val="111820"/>
                 </a:solidFill>
+                <a:latin typeface="Calibri"/>
+              </a:rPr>
+              <a:t>Screen 1: harness decisions; the scope layer writes </a:t>
+            </a:r>
+            <a:r>
+              <a:rPr sz="2100" b="0">
+                <a:solidFill>
+                  <a:srgbClr val="111820"/>
+                </a:solidFill>
                 <a:latin typeface="Consolas"/>
               </a:rPr>
-              <a:t>make show-3</a:t>
-            </a:r>
-            <a:r>
-              <a:rPr sz="2100" b="0">
-                <a:solidFill>
-                  <a:srgbClr val="111820"/>
-                </a:solidFill>
-                <a:latin typeface="Calibri"/>
-              </a:rPr>
-              <a:t>, finished: screen 1 lists blocked or reverted decisions with their reasons</a:t>
+              <a:t>feature_list.json</a:t>
+            </a:r>
+            <a:r>
+              <a:rPr sz="2100" b="0">
+                <a:solidFill>
+                  <a:srgbClr val="111820"/>
+                </a:solidFill>
+                <a:latin typeface="Calibri"/>
+              </a:rPr>
+              <a:t> with F3, </a:t>
+            </a:r>
+            <a:r>
+              <a:rPr sz="2100" b="0">
+                <a:solidFill>
+                  <a:srgbClr val="111820"/>
+                </a:solidFill>
+                <a:latin typeface="Consolas"/>
+              </a:rPr>
+              <a:t>passes: false</a:t>
             </a:r>
           </a:p>
           <a:p>
@@ -28653,25 +28915,7 @@
                 </a:solidFill>
                 <a:latin typeface="Calibri"/>
               </a:rPr>
-              <a:t>Screen 3: the diff map and any </a:t>
-            </a:r>
-            <a:r>
-              <a:rPr sz="2100" b="0">
-                <a:solidFill>
-                  <a:srgbClr val="111820"/>
-                </a:solidFill>
-                <a:latin typeface="Consolas"/>
-              </a:rPr>
-              <a:t>sandbox_denied</a:t>
-            </a:r>
-            <a:r>
-              <a:rPr sz="2100" b="0">
-                <a:solidFill>
-                  <a:srgbClr val="111820"/>
-                </a:solidFill>
-                <a:latin typeface="Calibri"/>
-              </a:rPr>
-              <a:t> event</a:t>
+              <a:t>A ⊘ block or ↺ revert appears only if the agent tries an edit outside the allow list</a:t>
             </a:r>
           </a:p>
           <a:p>
@@ -28696,25 +28940,7 @@
                 </a:solidFill>
                 <a:latin typeface="Calibri"/>
               </a:rPr>
-              <a:t>Real run, replayed: </a:t>
-            </a:r>
-            <a:r>
-              <a:rPr sz="2100" b="0">
-                <a:solidFill>
-                  <a:srgbClr val="111820"/>
-                </a:solidFill>
-                <a:latin typeface="Consolas"/>
-              </a:rPr>
-              <a:t>make replay RUN=ab-20261016-214151-ca9841</a:t>
-            </a:r>
-            <a:r>
-              <a:rPr sz="2100" b="0">
-                <a:solidFill>
-                  <a:srgbClr val="111820"/>
-                </a:solidFill>
-                <a:latin typeface="Calibri"/>
-              </a:rPr>
-              <a:t> (pilot run 3, F4)</a:t>
+              <a:t>Screen 3: the diff map and "Sandbox denials"; screen 5: the trace links</a:t>
             </a:r>
           </a:p>
           <a:p>
@@ -28739,14 +28965,38 @@
                 </a:solidFill>
                 <a:latin typeface="Calibri"/>
               </a:rPr>
-              <a:t>Its bare arm changed 2 files outside the allowed paths; its harness arm, with the scope layer, 0</a:t>
-            </a:r>
-          </a:p>
-        </p:txBody>
-      </p:sp>
-      <p:sp>
-        <p:nvSpPr>
-          <p:cNvPr id="9" name="Rectangle 8"/>
+              <a:t>Console screen 1 (show-3), captured on 2026-10-17, run ab-20261017-114259-b64f54; your output will differ</a:t>
+            </a:r>
+          </a:p>
+        </p:txBody>
+      </p:sp>
+      <p:pic>
+        <p:nvPicPr>
+          <p:cNvPr id="9" name="Picture 8" descr="s3-watch.png"/>
+          <p:cNvPicPr>
+            <a:picLocks noChangeAspect="1"/>
+          </p:cNvPicPr>
+          <p:nvPr/>
+        </p:nvPicPr>
+        <p:blipFill>
+          <a:blip r:embed="rId2"/>
+          <a:stretch>
+            <a:fillRect/>
+          </a:stretch>
+        </p:blipFill>
+        <p:spPr>
+          <a:xfrm>
+            <a:off x="6111665" y="1219200"/>
+            <a:ext cx="5326594" cy="4705350"/>
+          </a:xfrm>
+          <a:prstGeom prst="rect">
+            <a:avLst/>
+          </a:prstGeom>
+        </p:spPr>
+      </p:pic>
+      <p:sp>
+        <p:nvSpPr>
+          <p:cNvPr id="10" name="Rectangle 9"/>
           <p:cNvSpPr/>
           <p:nvPr/>
         </p:nvSpPr>
@@ -28792,7 +29042,7 @@
       </p:sp>
       <p:sp>
         <p:nvSpPr>
-          <p:cNvPr id="10" name="TextBox 9"/>
+          <p:cNvPr id="11" name="TextBox 10"/>
           <p:cNvSpPr txBox="1"/>
           <p:nvPr/>
         </p:nvSpPr>
@@ -29081,7 +29331,7 @@
         <p:spPr>
           <a:xfrm>
             <a:off x="533400" y="628650"/>
-            <a:ext cx="11125200" cy="933450"/>
+            <a:ext cx="11125200" cy="495300"/>
           </a:xfrm>
           <a:prstGeom prst="rect">
             <a:avLst/>
@@ -29102,7 +29352,7 @@
                 </a:solidFill>
                 <a:latin typeface="Calibri"/>
               </a:rPr>
-              <a:t>Demo block: a constructed example, the sandbox, and what the pilot measured</a:t>
+              <a:t>Demo block: reading the result</a:t>
             </a:r>
           </a:p>
         </p:txBody>
@@ -29115,8 +29365,8 @@
         </p:nvSpPr>
         <p:spPr>
           <a:xfrm>
-            <a:off x="533400" y="1657350"/>
-            <a:ext cx="11125200" cy="4743450"/>
+            <a:off x="533400" y="1219200"/>
+            <a:ext cx="11125200" cy="3351848"/>
           </a:xfrm>
           <a:prstGeom prst="rect">
             <a:avLst/>
@@ -29131,11 +29381,11 @@
           <a:p>
             <a:pPr algn="l">
               <a:spcAft>
-                <a:spcPts val="945"/>
+                <a:spcPts val="776"/>
               </a:spcAft>
             </a:pPr>
             <a:r>
-              <a:rPr sz="2100" b="0">
+              <a:rPr sz="1725" b="0">
                 <a:solidFill>
                   <a:srgbClr val="111820"/>
                 </a:solidFill>
@@ -29144,41 +29394,23 @@
               <a:t>•  </a:t>
             </a:r>
             <a:r>
-              <a:rPr sz="2100" b="0">
-                <a:solidFill>
-                  <a:srgbClr val="111820"/>
-                </a:solidFill>
-                <a:latin typeface="Calibri"/>
-              </a:rPr>
-              <a:t>Constructed example: </a:t>
-            </a:r>
-            <a:r>
-              <a:rPr sz="2100" b="0">
-                <a:solidFill>
-                  <a:srgbClr val="111820"/>
-                </a:solidFill>
-                <a:latin typeface="Consolas"/>
-              </a:rPr>
-              <a:t>make example-3</a:t>
-            </a:r>
-            <a:r>
-              <a:rPr sz="2100" b="0">
-                <a:solidFill>
-                  <a:srgbClr val="111820"/>
-                </a:solidFill>
-                <a:latin typeface="Calibri"/>
-              </a:rPr>
-              <a:t>, scripted, no model; CONSTRUCTED EXAMPLE on every screen</a:t>
+              <a:rPr sz="1725" b="0">
+                <a:solidFill>
+                  <a:srgbClr val="111820"/>
+                </a:solidFill>
+                <a:latin typeface="Calibri"/>
+              </a:rPr>
+              <a:t>show-3 in the quiet run: out-of-scope files 0, test-phase source edits 0 (passes); hidden tests 49 of 49, mutants killed 4 of 4</a:t>
             </a:r>
           </a:p>
           <a:p>
             <a:pPr algn="l">
               <a:spcAft>
-                <a:spcPts val="945"/>
+                <a:spcPts val="776"/>
               </a:spcAft>
             </a:pPr>
             <a:r>
-              <a:rPr sz="2100" b="0">
+              <a:rPr sz="1725" b="0">
                 <a:solidFill>
                   <a:srgbClr val="111820"/>
                 </a:solidFill>
@@ -29187,41 +29419,23 @@
               <a:t>•  </a:t>
             </a:r>
             <a:r>
-              <a:rPr sz="2100" b="0">
-                <a:solidFill>
-                  <a:srgbClr val="111820"/>
-                </a:solidFill>
-                <a:latin typeface="Calibri"/>
-              </a:rPr>
-              <a:t>Sandbox moment: no pilot A/B recorded a </a:t>
-            </a:r>
-            <a:r>
-              <a:rPr sz="2100" b="0">
-                <a:solidFill>
-                  <a:srgbClr val="111820"/>
-                </a:solidFill>
-                <a:latin typeface="Consolas"/>
-              </a:rPr>
-              <a:t>sandbox_denied</a:t>
-            </a:r>
-            <a:r>
-              <a:rPr sz="2100" b="0">
-                <a:solidFill>
-                  <a:srgbClr val="111820"/>
-                </a:solidFill>
-                <a:latin typeface="Calibri"/>
-              </a:rPr>
-              <a:t> event; show the policy printout</a:t>
+              <a:rPr sz="1725" b="0">
+                <a:solidFill>
+                  <a:srgbClr val="111820"/>
+                </a:solidFill>
+                <a:latin typeface="Calibri"/>
+              </a:rPr>
+              <a:t>The harness arm's zero is expected by construction; the question is whether it still shipped a working feature</a:t>
             </a:r>
           </a:p>
           <a:p>
             <a:pPr algn="l">
               <a:spcAft>
-                <a:spcPts val="945"/>
+                <a:spcPts val="776"/>
               </a:spcAft>
             </a:pPr>
             <a:r>
-              <a:rPr sz="2100" b="0">
+              <a:rPr sz="1725" b="0">
                 <a:solidFill>
                   <a:srgbClr val="111820"/>
                 </a:solidFill>
@@ -29230,7 +29444,7 @@
               <a:t>•  </a:t>
             </a:r>
             <a:r>
-              <a:rPr sz="2100" b="0">
+              <a:rPr sz="1725" b="0">
                 <a:solidFill>
                   <a:srgbClr val="111820"/>
                 </a:solidFill>
@@ -29242,11 +29456,11 @@
           <a:p>
             <a:pPr algn="l">
               <a:spcAft>
-                <a:spcPts val="945"/>
+                <a:spcPts val="776"/>
               </a:spcAft>
             </a:pPr>
             <a:r>
-              <a:rPr sz="2100" b="0">
+              <a:rPr sz="1725" b="0">
                 <a:solidFill>
                   <a:srgbClr val="111820"/>
                 </a:solidFill>
@@ -29255,23 +29469,23 @@
               <a:t>•  </a:t>
             </a:r>
             <a:r>
-              <a:rPr sz="2100" b="0">
-                <a:solidFill>
-                  <a:srgbClr val="111820"/>
-                </a:solidFill>
-                <a:latin typeface="Calibri"/>
-              </a:rPr>
-              <a:t>Post hoc, F3 (9 runs per arm): harness arms shipped a median of 0 tests against 6; claimed done in 4 against 9</a:t>
+              <a:rPr sz="1725" b="0">
+                <a:solidFill>
+                  <a:srgbClr val="111820"/>
+                </a:solidFill>
+                <a:latin typeface="Calibri"/>
+              </a:rPr>
+              <a:t>Scope was registered only for F3; the F4 count (post hoc) is a reason to register it next time, not a result</a:t>
             </a:r>
           </a:p>
           <a:p>
             <a:pPr algn="l">
               <a:spcAft>
-                <a:spcPts val="945"/>
+                <a:spcPts val="776"/>
               </a:spcAft>
             </a:pPr>
             <a:r>
-              <a:rPr sz="2100" b="0">
+              <a:rPr sz="1725" b="0">
                 <a:solidFill>
                   <a:srgbClr val="111820"/>
                 </a:solidFill>
@@ -29280,42 +29494,41 @@
               <a:t>•  </a:t>
             </a:r>
             <a:r>
-              <a:rPr sz="2100" b="0">
-                <a:solidFill>
-                  <a:srgbClr val="111820"/>
-                </a:solidFill>
-                <a:latin typeface="Calibri"/>
-              </a:rPr>
-              <a:t>Post hoc, F4 (all four layers): bare arms left the allowed paths in 6 of 6 runs, harness arms in 0 of 6</a:t>
-            </a:r>
-          </a:p>
-          <a:p>
-            <a:pPr algn="l">
-              <a:spcAft>
-                <a:spcPts val="945"/>
-              </a:spcAft>
-            </a:pPr>
-            <a:r>
-              <a:rPr sz="2100" b="0">
-                <a:solidFill>
-                  <a:srgbClr val="111820"/>
-                </a:solidFill>
-                <a:latin typeface="Calibri"/>
-              </a:rPr>
-              <a:t>•  </a:t>
-            </a:r>
-            <a:r>
-              <a:rPr sz="2100" b="0">
-                <a:solidFill>
-                  <a:srgbClr val="111820"/>
-                </a:solidFill>
-                <a:latin typeface="Calibri"/>
-              </a:rPr>
-              <a:t>A measure nobody registered for scope: a reason to register it next time, not a result</a:t>
-            </a:r>
-          </a:p>
-        </p:txBody>
-      </p:sp>
+              <a:rPr sz="1725" b="0">
+                <a:solidFill>
+                  <a:srgbClr val="111820"/>
+                </a:solidFill>
+                <a:latin typeface="Calibri"/>
+              </a:rPr>
+              <a:t>Console screen 3 (show-3), captured on 2026-10-17, run ab-20261017-114259-b64f54; your output will differ</a:t>
+            </a:r>
+          </a:p>
+        </p:txBody>
+      </p:sp>
+      <p:pic>
+        <p:nvPicPr>
+          <p:cNvPr id="9" name="Picture 8" descr="s3-result.png"/>
+          <p:cNvPicPr>
+            <a:picLocks noChangeAspect="1"/>
+          </p:cNvPicPr>
+          <p:nvPr/>
+        </p:nvPicPr>
+        <p:blipFill>
+          <a:blip r:embed="rId2"/>
+          <a:stretch>
+            <a:fillRect/>
+          </a:stretch>
+        </p:blipFill>
+        <p:spPr>
+          <a:xfrm>
+            <a:off x="2850569" y="4666298"/>
+            <a:ext cx="6490862" cy="1734503"/>
+          </a:xfrm>
+          <a:prstGeom prst="rect">
+            <a:avLst/>
+          </a:prstGeom>
+        </p:spPr>
+      </p:pic>
     </p:spTree>
   </p:cSld>
   <p:clrMapOvr>
@@ -29639,7 +29852,7 @@
                 </a:solidFill>
                 <a:latin typeface="Calibri"/>
               </a:rPr>
-              <a:t>Discussion: the scope layer's clearest effect showed where it was not the primary measure. How would you register that before the next run?</a:t>
+              <a:t>Discussion: the clearest post hoc difference showed where scope was not the primary measure. How would you register that before the next run?</a:t>
             </a:r>
           </a:p>
           <a:p>
@@ -31573,7 +31786,7 @@
         <p:spPr>
           <a:xfrm>
             <a:off x="533400" y="1219200"/>
-            <a:ext cx="11125200" cy="5181600"/>
+            <a:ext cx="11125200" cy="3264408"/>
           </a:xfrm>
           <a:prstGeom prst="rect">
             <a:avLst/>
@@ -31693,7 +31906,7 @@
                 </a:solidFill>
                 <a:latin typeface="Calibri"/>
               </a:rPr>
-              <a:t>show-4: the harness arm alone on F4; watch the handoffs, the test phase, and the filters</a:t>
+              <a:t>show-4: the harness arm alone on F4; watch the gate, the test phase, and the filters</a:t>
             </a:r>
           </a:p>
           <a:p>
@@ -31721,33 +31934,32 @@
               <a:t>The final is tonight's one live A/B: both arms, all four layers, blinded reviewer on both diffs</a:t>
             </a:r>
           </a:p>
-          <a:p>
-            <a:pPr algn="l">
-              <a:spcAft>
-                <a:spcPts val="945"/>
-              </a:spcAft>
-            </a:pPr>
-            <a:r>
-              <a:rPr sz="2100" b="0">
-                <a:solidFill>
-                  <a:srgbClr val="111820"/>
-                </a:solidFill>
-                <a:latin typeface="Calibri"/>
-              </a:rPr>
-              <a:t>•  </a:t>
-            </a:r>
-            <a:r>
-              <a:rPr sz="2100" b="0">
-                <a:solidFill>
-                  <a:srgbClr val="111820"/>
-                </a:solidFill>
-                <a:latin typeface="Calibri"/>
-              </a:rPr>
-              <a:t>Class profile for both arms; final run cap $0.25 per arm</a:t>
-            </a:r>
-          </a:p>
-        </p:txBody>
-      </p:sp>
+        </p:txBody>
+      </p:sp>
+      <p:pic>
+        <p:nvPicPr>
+          <p:cNvPr id="9" name="Picture 8" descr="4fd6deeee6fbd5a4.png"/>
+          <p:cNvPicPr>
+            <a:picLocks noChangeAspect="1"/>
+          </p:cNvPicPr>
+          <p:nvPr/>
+        </p:nvPicPr>
+        <p:blipFill>
+          <a:blip r:embed="rId2"/>
+          <a:stretch>
+            <a:fillRect/>
+          </a:stretch>
+        </p:blipFill>
+        <p:spPr>
+          <a:xfrm>
+            <a:off x="533400" y="4625109"/>
+            <a:ext cx="11125200" cy="1729439"/>
+          </a:xfrm>
+          <a:prstGeom prst="rect">
+            <a:avLst/>
+          </a:prstGeom>
+        </p:spPr>
+      </p:pic>
     </p:spTree>
   </p:cSld>
   <p:clrMapOvr>
@@ -35934,7 +36146,7 @@
         <p:spPr>
           <a:xfrm>
             <a:off x="533400" y="1219200"/>
-            <a:ext cx="11125200" cy="1383487"/>
+            <a:ext cx="11125200" cy="1297019"/>
           </a:xfrm>
           <a:prstGeom prst="rect">
             <a:avLst/>
@@ -35949,11 +36161,11 @@
           <a:p>
             <a:pPr algn="l">
               <a:spcAft>
-                <a:spcPts val="918"/>
+                <a:spcPts val="860"/>
               </a:spcAft>
             </a:pPr>
             <a:r>
-              <a:rPr sz="2039" b="0">
+              <a:rPr sz="1912" b="0">
                 <a:solidFill>
                   <a:srgbClr val="111820"/>
                 </a:solidFill>
@@ -35962,7 +36174,7 @@
               <a:t>•  </a:t>
             </a:r>
             <a:r>
-              <a:rPr sz="2039" b="0">
+              <a:rPr sz="1912" b="0">
                 <a:solidFill>
                   <a:srgbClr val="111820"/>
                 </a:solidFill>
@@ -35974,11 +36186,11 @@
           <a:p>
             <a:pPr algn="l">
               <a:spcAft>
-                <a:spcPts val="918"/>
+                <a:spcPts val="860"/>
               </a:spcAft>
             </a:pPr>
             <a:r>
-              <a:rPr sz="2039" b="0">
+              <a:rPr sz="1912" b="0">
                 <a:solidFill>
                   <a:srgbClr val="111820"/>
                 </a:solidFill>
@@ -35987,7 +36199,7 @@
               <a:t>•  </a:t>
             </a:r>
             <a:r>
-              <a:rPr sz="2039" b="0">
+              <a:rPr sz="1912" b="0">
                 <a:solidFill>
                   <a:srgbClr val="111820"/>
                 </a:solidFill>
@@ -35999,11 +36211,11 @@
           <a:p>
             <a:pPr algn="l">
               <a:spcAft>
-                <a:spcPts val="918"/>
+                <a:spcPts val="860"/>
               </a:spcAft>
             </a:pPr>
             <a:r>
-              <a:rPr sz="2039" b="0">
+              <a:rPr sz="1912" b="0">
                 <a:solidFill>
                   <a:srgbClr val="111820"/>
                 </a:solidFill>
@@ -36012,7 +36224,7 @@
               <a:t>•  </a:t>
             </a:r>
             <a:r>
-              <a:rPr sz="2039" b="0">
+              <a:rPr sz="1912" b="0">
                 <a:solidFill>
                   <a:srgbClr val="111820"/>
                 </a:solidFill>
@@ -36031,8 +36243,8 @@
         </p:nvSpPr>
         <p:spPr>
           <a:xfrm>
-            <a:off x="533400" y="2697937"/>
-            <a:ext cx="11125200" cy="3301944"/>
+            <a:off x="533400" y="2611469"/>
+            <a:ext cx="11125200" cy="3352110"/>
           </a:xfrm>
           <a:prstGeom prst="rect">
             <a:avLst/>
@@ -36077,8 +36289,8 @@
         </p:nvSpPr>
         <p:spPr>
           <a:xfrm>
-            <a:off x="533400" y="2697937"/>
-            <a:ext cx="57150" cy="3301944"/>
+            <a:off x="533400" y="2611469"/>
+            <a:ext cx="57150" cy="3352110"/>
           </a:xfrm>
           <a:prstGeom prst="rect">
             <a:avLst/>
@@ -36121,8 +36333,8 @@
         </p:nvSpPr>
         <p:spPr>
           <a:xfrm>
-            <a:off x="704850" y="2793187"/>
-            <a:ext cx="10858500" cy="3149544"/>
+            <a:off x="704850" y="2706719"/>
+            <a:ext cx="10858500" cy="3199710"/>
           </a:xfrm>
           <a:prstGeom prst="rect">
             <a:avLst/>
@@ -36137,7 +36349,7 @@
           <a:p>
             <a:pPr algn="l"/>
             <a:r>
-              <a:rPr sz="1527" b="0">
+              <a:rPr sz="1433" b="0">
                 <a:solidFill>
                   <a:srgbClr val="111820"/>
                 </a:solidFill>
@@ -36149,7 +36361,7 @@
           <a:p>
             <a:pPr algn="l"/>
             <a:r>
-              <a:rPr sz="1527" b="0">
+              <a:rPr sz="1433" b="0">
                 <a:solidFill>
                   <a:srgbClr val="111820"/>
                 </a:solidFill>
@@ -36161,7 +36373,7 @@
           <a:p>
             <a:pPr algn="l"/>
             <a:r>
-              <a:rPr sz="1527" b="0">
+              <a:rPr sz="1433" b="0">
                 <a:solidFill>
                   <a:srgbClr val="111820"/>
                 </a:solidFill>
@@ -36173,7 +36385,7 @@
           <a:p>
             <a:pPr algn="l"/>
             <a:r>
-              <a:rPr sz="1527" b="0">
+              <a:rPr sz="1433" b="0">
                 <a:solidFill>
                   <a:srgbClr val="111820"/>
                 </a:solidFill>
@@ -36185,7 +36397,7 @@
           <a:p>
             <a:pPr algn="l"/>
             <a:r>
-              <a:rPr sz="1527" b="0">
+              <a:rPr sz="1433" b="0">
                 <a:solidFill>
                   <a:srgbClr val="111820"/>
                 </a:solidFill>
@@ -36197,7 +36409,7 @@
           <a:p>
             <a:pPr algn="l"/>
             <a:r>
-              <a:rPr sz="1527" b="0">
+              <a:rPr sz="1433" b="0">
                 <a:solidFill>
                   <a:srgbClr val="111820"/>
                 </a:solidFill>
@@ -36209,31 +36421,43 @@
           <a:p>
             <a:pPr algn="l"/>
             <a:r>
-              <a:rPr sz="1527" b="0">
+              <a:rPr sz="1433" b="0">
                 <a:solidFill>
                   <a:srgbClr val="111820"/>
                 </a:solidFill>
                 <a:latin typeface="Consolas"/>
               </a:rPr>
-              <a:t>clean = clean_state_check(sandbox, base_sha, cfg.limit(120))</a:t>
+              <a:t>clean = clean_state_check(</a:t>
             </a:r>
           </a:p>
           <a:p>
             <a:pPr algn="l"/>
             <a:r>
-              <a:rPr sz="1527" b="0">
+              <a:rPr sz="1433" b="0">
                 <a:solidFill>
                   <a:srgbClr val="111820"/>
                 </a:solidFill>
                 <a:latin typeface="Consolas"/>
               </a:rPr>
+              <a:t>...</a:t>
+            </a:r>
+          </a:p>
+          <a:p>
+            <a:pPr algn="l"/>
+            <a:r>
+              <a:rPr sz="1433" b="0">
+                <a:solidFill>
+                  <a:srgbClr val="111820"/>
+                </a:solidFill>
+                <a:latin typeface="Consolas"/>
+              </a:rPr>
               <a:t>items.append(clean)</a:t>
             </a:r>
           </a:p>
           <a:p>
             <a:pPr algn="l"/>
             <a:r>
-              <a:rPr sz="1527" b="0">
+              <a:rPr sz="1433" b="0">
                 <a:solidFill>
                   <a:srgbClr val="111820"/>
                 </a:solidFill>
@@ -36245,7 +36469,7 @@
           <a:p>
             <a:pPr algn="l"/>
             <a:r>
-              <a:rPr sz="1527" b="0">
+              <a:rPr sz="1433" b="0">
                 <a:solidFill>
                   <a:srgbClr val="111820"/>
                 </a:solidFill>
@@ -36257,7 +36481,7 @@
           <a:p>
             <a:pPr algn="l"/>
             <a:r>
-              <a:rPr sz="1527" b="0">
+              <a:rPr sz="1433" b="0">
                 <a:solidFill>
                   <a:srgbClr val="111820"/>
                 </a:solidFill>
@@ -36269,7 +36493,7 @@
           <a:p>
             <a:pPr algn="l"/>
             <a:r>
-              <a:rPr sz="1527" b="0">
+              <a:rPr sz="1433" b="0">
                 <a:solidFill>
                   <a:srgbClr val="111820"/>
                 </a:solidFill>
@@ -36288,7 +36512,7 @@
         </p:nvSpPr>
         <p:spPr>
           <a:xfrm>
-            <a:off x="533400" y="6018931"/>
+            <a:off x="533400" y="5982630"/>
             <a:ext cx="11125200" cy="209550"/>
           </a:xfrm>
           <a:prstGeom prst="rect">
@@ -36556,7 +36780,7 @@
                 </a:solidFill>
                 <a:latin typeface="Calibri"/>
               </a:rPr>
-              <a:t>Demo block: harness in action, and a real run replayed</a:t>
+              <a:t>Demo block: what to watch</a:t>
             </a:r>
           </a:p>
         </p:txBody>
@@ -36570,7 +36794,7 @@
         <p:spPr>
           <a:xfrm>
             <a:off x="533400" y="1219200"/>
-            <a:ext cx="11125200" cy="4705350"/>
+            <a:ext cx="11125200" cy="1918811"/>
           </a:xfrm>
           <a:prstGeom prst="rect">
             <a:avLst/>
@@ -36585,11 +36809,11 @@
           <a:p>
             <a:pPr algn="l">
               <a:spcAft>
-                <a:spcPts val="945"/>
+                <a:spcPts val="860"/>
               </a:spcAft>
             </a:pPr>
             <a:r>
-              <a:rPr sz="2100" b="0">
+              <a:rPr sz="1912" b="0">
                 <a:solidFill>
                   <a:srgbClr val="111820"/>
                 </a:solidFill>
@@ -36598,32 +36822,23 @@
               <a:t>•  </a:t>
             </a:r>
             <a:r>
-              <a:rPr sz="2100" b="0">
-                <a:solidFill>
-                  <a:srgbClr val="111820"/>
-                </a:solidFill>
-                <a:latin typeface="Consolas"/>
-              </a:rPr>
-              <a:t>make show-4</a:t>
-            </a:r>
-            <a:r>
-              <a:rPr sz="2100" b="0">
-                <a:solidFill>
-                  <a:srgbClr val="111820"/>
-                </a:solidFill>
-                <a:latin typeface="Calibri"/>
-              </a:rPr>
-              <a:t>, finished: screen 1 shows the gate pills ✓ or ✗ and the gate feedback</a:t>
+              <a:rPr sz="1912" b="0">
+                <a:solidFill>
+                  <a:srgbClr val="111820"/>
+                </a:solidFill>
+                <a:latin typeface="Calibri"/>
+              </a:rPr>
+              <a:t>Screen 1: a ⊘ blocked edit, "done" and the gate pills, then the test phase; screen 2: the conflict panel</a:t>
             </a:r>
           </a:p>
           <a:p>
             <a:pPr algn="l">
               <a:spcAft>
-                <a:spcPts val="945"/>
+                <a:spcPts val="860"/>
               </a:spcAft>
             </a:pPr>
             <a:r>
-              <a:rPr sz="2100" b="0">
+              <a:rPr sz="1912" b="0">
                 <a:solidFill>
                   <a:srgbClr val="111820"/>
                 </a:solidFill>
@@ -36632,23 +36847,23 @@
               <a:t>•  </a:t>
             </a:r>
             <a:r>
-              <a:rPr sz="2100" b="0">
-                <a:solidFill>
-                  <a:srgbClr val="111820"/>
-                </a:solidFill>
-                <a:latin typeface="Calibri"/>
-              </a:rPr>
-              <a:t>Screen 3: the filter table with discard reasons, the mutant table, the referee counters</a:t>
+              <a:rPr sz="1912" b="0">
+                <a:solidFill>
+                  <a:srgbClr val="111820"/>
+                </a:solidFill>
+                <a:latin typeface="Calibri"/>
+              </a:rPr>
+              <a:t>Screen 3: the filter table (kept or discarded, with the reason) and the mutant table</a:t>
             </a:r>
           </a:p>
           <a:p>
             <a:pPr algn="l">
               <a:spcAft>
-                <a:spcPts val="945"/>
+                <a:spcPts val="860"/>
               </a:spcAft>
             </a:pPr>
             <a:r>
-              <a:rPr sz="2100" b="0">
+              <a:rPr sz="1912" b="0">
                 <a:solidFill>
                   <a:srgbClr val="111820"/>
                 </a:solidFill>
@@ -36657,63 +36872,44 @@
               <a:t>•  </a:t>
             </a:r>
             <a:r>
-              <a:rPr sz="2100" b="0">
-                <a:solidFill>
-                  <a:srgbClr val="111820"/>
-                </a:solidFill>
-                <a:latin typeface="Calibri"/>
-              </a:rPr>
-              <a:t>Real run, replayed: </a:t>
-            </a:r>
-            <a:r>
-              <a:rPr sz="2100" b="0">
-                <a:solidFill>
-                  <a:srgbClr val="111820"/>
-                </a:solidFill>
-                <a:latin typeface="Consolas"/>
-              </a:rPr>
-              <a:t>make replay RUN=ab-20261017-090903-926c02</a:t>
-            </a:r>
-            <a:r>
-              <a:rPr sz="2100" b="0">
-                <a:solidFill>
-                  <a:srgbClr val="111820"/>
-                </a:solidFill>
-                <a:latin typeface="Calibri"/>
-              </a:rPr>
-              <a:t> (class-profile round, F4)</a:t>
-            </a:r>
-          </a:p>
-          <a:p>
-            <a:pPr algn="l">
-              <a:spcAft>
-                <a:spcPts val="945"/>
-              </a:spcAft>
-            </a:pPr>
-            <a:r>
-              <a:rPr sz="2100" b="0">
-                <a:solidFill>
-                  <a:srgbClr val="111820"/>
-                </a:solidFill>
-                <a:latin typeface="Calibri"/>
-              </a:rPr>
-              <a:t>•  </a:t>
-            </a:r>
-            <a:r>
-              <a:rPr sz="2100" b="0">
-                <a:solidFill>
-                  <a:srgbClr val="111820"/>
-                </a:solidFill>
-                <a:latin typeface="Calibri"/>
-              </a:rPr>
-              <a:t>Its bare arm claimed done with 68 of 69 hidden tests passing; the referee failed the run</a:t>
-            </a:r>
-          </a:p>
-        </p:txBody>
-      </p:sp>
-      <p:sp>
-        <p:nvSpPr>
-          <p:cNvPr id="9" name="Rectangle 8"/>
+              <a:rPr sz="1912" b="0">
+                <a:solidFill>
+                  <a:srgbClr val="111820"/>
+                </a:solidFill>
+                <a:latin typeface="Calibri"/>
+              </a:rPr>
+              <a:t>Console screens 1 and 2 (show-4), captured on 2026-10-17, run ab-20261017-115138-c45d9d; your output will differ</a:t>
+            </a:r>
+          </a:p>
+        </p:txBody>
+      </p:sp>
+      <p:pic>
+        <p:nvPicPr>
+          <p:cNvPr id="9" name="Picture 8" descr="s4-watch.png"/>
+          <p:cNvPicPr>
+            <a:picLocks noChangeAspect="1"/>
+          </p:cNvPicPr>
+          <p:nvPr/>
+        </p:nvPicPr>
+        <p:blipFill>
+          <a:blip r:embed="rId2"/>
+          <a:stretch>
+            <a:fillRect/>
+          </a:stretch>
+        </p:blipFill>
+        <p:spPr>
+          <a:xfrm>
+            <a:off x="3600606" y="3233261"/>
+            <a:ext cx="4990789" cy="2691289"/>
+          </a:xfrm>
+          <a:prstGeom prst="rect">
+            <a:avLst/>
+          </a:prstGeom>
+        </p:spPr>
+      </p:pic>
+      <p:sp>
+        <p:nvSpPr>
+          <p:cNvPr id="10" name="Rectangle 9"/>
           <p:cNvSpPr/>
           <p:nvPr/>
         </p:nvSpPr>
@@ -36759,7 +36955,7 @@
       </p:sp>
       <p:sp>
         <p:nvSpPr>
-          <p:cNvPr id="10" name="TextBox 9"/>
+          <p:cNvPr id="11" name="TextBox 10"/>
           <p:cNvSpPr txBox="1"/>
           <p:nvPr/>
         </p:nvSpPr>
@@ -37030,7 +37226,7 @@
         <p:spPr>
           <a:xfrm>
             <a:off x="533400" y="628650"/>
-            <a:ext cx="11125200" cy="933450"/>
+            <a:ext cx="11125200" cy="495300"/>
           </a:xfrm>
           <a:prstGeom prst="rect">
             <a:avLst/>
@@ -37051,7 +37247,7 @@
                 </a:solidFill>
                 <a:latin typeface="Calibri"/>
               </a:rPr>
-              <a:t>Demo block: a constructed example, and what the pilot measured</a:t>
+              <a:t>Demo block: reading the result</a:t>
             </a:r>
           </a:p>
         </p:txBody>
@@ -37064,8 +37260,8 @@
         </p:nvSpPr>
         <p:spPr>
           <a:xfrm>
-            <a:off x="533400" y="1657350"/>
-            <a:ext cx="11125200" cy="4743450"/>
+            <a:off x="533400" y="1219200"/>
+            <a:ext cx="5015023" cy="5181600"/>
           </a:xfrm>
           <a:prstGeom prst="rect">
             <a:avLst/>
@@ -37080,11 +37276,11 @@
           <a:p>
             <a:pPr algn="l">
               <a:spcAft>
-                <a:spcPts val="945"/>
+                <a:spcPts val="776"/>
               </a:spcAft>
             </a:pPr>
             <a:r>
-              <a:rPr sz="2100" b="0">
+              <a:rPr sz="1725" b="0">
                 <a:solidFill>
                   <a:srgbClr val="111820"/>
                 </a:solidFill>
@@ -37093,41 +37289,23 @@
               <a:t>•  </a:t>
             </a:r>
             <a:r>
-              <a:rPr sz="2100" b="0">
-                <a:solidFill>
-                  <a:srgbClr val="111820"/>
-                </a:solidFill>
-                <a:latin typeface="Calibri"/>
-              </a:rPr>
-              <a:t>Constructed example: </a:t>
-            </a:r>
-            <a:r>
-              <a:rPr sz="2100" b="0">
-                <a:solidFill>
-                  <a:srgbClr val="111820"/>
-                </a:solidFill>
-                <a:latin typeface="Consolas"/>
-              </a:rPr>
-              <a:t>make example-4</a:t>
-            </a:r>
-            <a:r>
-              <a:rPr sz="2100" b="0">
-                <a:solidFill>
-                  <a:srgbClr val="111820"/>
-                </a:solidFill>
-                <a:latin typeface="Calibri"/>
-              </a:rPr>
-              <a:t>, scripted, no model; CONSTRUCTED EXAMPLE on every screen</a:t>
+              <a:rPr sz="1725" b="0">
+                <a:solidFill>
+                  <a:srgbClr val="111820"/>
+                </a:solidFill>
+                <a:latin typeface="Calibri"/>
+              </a:rPr>
+              <a:t>show-4 in the quiet run: the gate passed and the agent said done; the referee found hidden tests 68 of 69, mutants killed 0 of 4: fails</a:t>
             </a:r>
           </a:p>
           <a:p>
             <a:pPr algn="l">
               <a:spcAft>
-                <a:spcPts val="945"/>
+                <a:spcPts val="776"/>
               </a:spcAft>
             </a:pPr>
             <a:r>
-              <a:rPr sz="2100" b="0">
+              <a:rPr sz="1725" b="0">
                 <a:solidFill>
                   <a:srgbClr val="111820"/>
                 </a:solidFill>
@@ -37136,23 +37314,23 @@
               <a:t>•  </a:t>
             </a:r>
             <a:r>
-              <a:rPr sz="2100" b="0">
-                <a:solidFill>
-                  <a:srgbClr val="111820"/>
-                </a:solidFill>
-                <a:latin typeface="Calibri"/>
-              </a:rPr>
-              <a:t>Pilot, all 69 hidden tests and all 4 mutants: bare 0 of 4 passing, harness 0 of 4 (poll answer: D); no measurable difference on this task with this model</a:t>
+              <a:rPr sz="1725" b="0">
+                <a:solidFill>
+                  <a:srgbClr val="111820"/>
+                </a:solidFill>
+                <a:latin typeface="Calibri"/>
+              </a:rPr>
+              <a:t>The gate checks visible tests and house rules; hidden tests and referee mutants stay out of its reach</a:t>
             </a:r>
           </a:p>
           <a:p>
             <a:pPr algn="l">
               <a:spcAft>
-                <a:spcPts val="945"/>
+                <a:spcPts val="776"/>
               </a:spcAft>
             </a:pPr>
             <a:r>
-              <a:rPr sz="2100" b="0">
+              <a:rPr sz="1725" b="0">
                 <a:solidFill>
                   <a:srgbClr val="111820"/>
                 </a:solidFill>
@@ -37161,23 +37339,23 @@
               <a:t>•  </a:t>
             </a:r>
             <a:r>
-              <a:rPr sz="2100" b="0">
-                <a:solidFill>
-                  <a:srgbClr val="111820"/>
-                </a:solidFill>
-                <a:latin typeface="Calibri"/>
-              </a:rPr>
-              <a:t>Run 3: every bare arm hit the agent time limit; the harness arms shipped no tests, so killed 0 of 4 mutants</a:t>
+              <a:rPr sz="1725" b="0">
+                <a:solidFill>
+                  <a:srgbClr val="111820"/>
+                </a:solidFill>
+                <a:latin typeface="Calibri"/>
+              </a:rPr>
+              <a:t>Pilot, all 69 hidden tests and all 4 mutants: bare 0 of 4 passing, harness 0 of 4 (poll answer: D); no measurable difference on this task with this model</a:t>
             </a:r>
           </a:p>
           <a:p>
             <a:pPr algn="l">
               <a:spcAft>
-                <a:spcPts val="945"/>
+                <a:spcPts val="776"/>
               </a:spcAft>
             </a:pPr>
             <a:r>
-              <a:rPr sz="2100" b="0">
+              <a:rPr sz="1725" b="0">
                 <a:solidFill>
                   <a:srgbClr val="111820"/>
                 </a:solidFill>
@@ -37186,23 +37364,23 @@
               <a:t>•  </a:t>
             </a:r>
             <a:r>
-              <a:rPr sz="2100" b="0">
-                <a:solidFill>
-                  <a:srgbClr val="111820"/>
-                </a:solidFill>
-                <a:latin typeface="Calibri"/>
-              </a:rPr>
-              <a:t>Class-profile round: both arms 68 of 69 hidden tests; mutants killed: bare 4, harness 1</a:t>
+              <a:rPr sz="1725" b="0">
+                <a:solidFill>
+                  <a:srgbClr val="111820"/>
+                </a:solidFill>
+                <a:latin typeface="Calibri"/>
+              </a:rPr>
+              <a:t>Class-profile round: the bare arm claimed done with 68 of 69 hidden tests, the first done claim with a failing hidden test in the pilot's records</a:t>
             </a:r>
           </a:p>
           <a:p>
             <a:pPr algn="l">
               <a:spcAft>
-                <a:spcPts val="945"/>
+                <a:spcPts val="776"/>
               </a:spcAft>
             </a:pPr>
             <a:r>
-              <a:rPr sz="2100" b="0">
+              <a:rPr sz="1725" b="0">
                 <a:solidFill>
                   <a:srgbClr val="111820"/>
                 </a:solidFill>
@@ -37211,42 +37389,41 @@
               <a:t>•  </a:t>
             </a:r>
             <a:r>
-              <a:rPr sz="2100" b="0">
-                <a:solidFill>
-                  <a:srgbClr val="111820"/>
-                </a:solidFill>
-                <a:latin typeface="Calibri"/>
-              </a:rPr>
-              <a:t>Post hoc, runs 2-4 (34 runs per arm): no done claim came with failing hidden tests (0 of 19 bare, 0 of 10 harness)</a:t>
-            </a:r>
-          </a:p>
-          <a:p>
-            <a:pPr algn="l">
-              <a:spcAft>
-                <a:spcPts val="945"/>
-              </a:spcAft>
-            </a:pPr>
-            <a:r>
-              <a:rPr sz="2100" b="0">
-                <a:solidFill>
-                  <a:srgbClr val="111820"/>
-                </a:solidFill>
-                <a:latin typeface="Calibri"/>
-              </a:rPr>
-              <a:t>•  </a:t>
-            </a:r>
-            <a:r>
-              <a:rPr sz="2100" b="0">
-                <a:solidFill>
-                  <a:srgbClr val="111820"/>
-                </a:solidFill>
-                <a:latin typeface="Calibri"/>
-              </a:rPr>
-              <a:t>The class-profile bare arm on slide 61 is the first done claim with a failing hidden test since</a:t>
-            </a:r>
-          </a:p>
-        </p:txBody>
-      </p:sp>
+              <a:rPr sz="1725" b="0">
+                <a:solidFill>
+                  <a:srgbClr val="111820"/>
+                </a:solidFill>
+                <a:latin typeface="Calibri"/>
+              </a:rPr>
+              <a:t>Console screen 3 (show-4), captured on 2026-10-17, run ab-20261017-115138-c45d9d; your output will differ</a:t>
+            </a:r>
+          </a:p>
+        </p:txBody>
+      </p:sp>
+      <p:pic>
+        <p:nvPicPr>
+          <p:cNvPr id="9" name="Picture 8" descr="s4-result.png"/>
+          <p:cNvPicPr>
+            <a:picLocks noChangeAspect="1"/>
+          </p:cNvPicPr>
+          <p:nvPr/>
+        </p:nvPicPr>
+        <p:blipFill>
+          <a:blip r:embed="rId2"/>
+          <a:stretch>
+            <a:fillRect/>
+          </a:stretch>
+        </p:blipFill>
+        <p:spPr>
+          <a:xfrm>
+            <a:off x="5891323" y="2121676"/>
+            <a:ext cx="5767277" cy="3376648"/>
+          </a:xfrm>
+          <a:prstGeom prst="rect">
+            <a:avLst/>
+          </a:prstGeom>
+        </p:spPr>
+      </p:pic>
     </p:spTree>
   </p:cSld>
   <p:clrMapOvr>
@@ -37971,7 +38148,7 @@
       </p:sp>
       <p:pic>
         <p:nvPicPr>
-          <p:cNvPr id="9" name="Picture 8" descr="8293c489a42b93a9.png"/>
+          <p:cNvPr id="9" name="Picture 8" descr="747a7c8219cfe3d2.png"/>
           <p:cNvPicPr>
             <a:picLocks noChangeAspect="1"/>
           </p:cNvPicPr>
@@ -37985,8 +38162,8 @@
         </p:blipFill>
         <p:spPr>
           <a:xfrm>
-            <a:off x="1378885" y="3213354"/>
-            <a:ext cx="9434229" cy="2711196"/>
+            <a:off x="533400" y="3986461"/>
+            <a:ext cx="11125200" cy="1164983"/>
           </a:xfrm>
           <a:prstGeom prst="rect">
             <a:avLst/>
@@ -38329,7 +38506,7 @@
         <p:spPr>
           <a:xfrm>
             <a:off x="533400" y="1219200"/>
-            <a:ext cx="11125200" cy="4705350"/>
+            <a:ext cx="11125200" cy="1918811"/>
           </a:xfrm>
           <a:prstGeom prst="rect">
             <a:avLst/>
@@ -38344,11 +38521,11 @@
           <a:p>
             <a:pPr algn="l">
               <a:spcAft>
-                <a:spcPts val="945"/>
+                <a:spcPts val="860"/>
               </a:spcAft>
             </a:pPr>
             <a:r>
-              <a:rPr sz="2100" b="0">
+              <a:rPr sz="1912" b="0">
                 <a:solidFill>
                   <a:srgbClr val="111820"/>
                 </a:solidFill>
@@ -38357,23 +38534,23 @@
               <a:t>•  </a:t>
             </a:r>
             <a:r>
-              <a:rPr sz="2100" b="0">
-                <a:solidFill>
-                  <a:srgbClr val="111820"/>
-                </a:solidFill>
-                <a:latin typeface="Calibri"/>
-              </a:rPr>
-              <a:t>Screen 1: the turns, harness decisions, gate pills, "primary verdict ready"</a:t>
+              <a:rPr sz="1912" b="0">
+                <a:solidFill>
+                  <a:srgbClr val="111820"/>
+                </a:solidFill>
+                <a:latin typeface="Calibri"/>
+              </a:rPr>
+              <a:t>Screen 1: the turns, harness decisions, gate pills, "primary verdict ready" per arm</a:t>
             </a:r>
           </a:p>
           <a:p>
             <a:pPr algn="l">
               <a:spcAft>
-                <a:spcPts val="945"/>
+                <a:spcPts val="860"/>
               </a:spcAft>
             </a:pPr>
             <a:r>
-              <a:rPr sz="2100" b="0">
+              <a:rPr sz="1912" b="0">
                 <a:solidFill>
                   <a:srgbClr val="111820"/>
                 </a:solidFill>
@@ -38382,23 +38559,23 @@
               <a:t>•  </a:t>
             </a:r>
             <a:r>
-              <a:rPr sz="2100" b="0">
-                <a:solidFill>
-                  <a:srgbClr val="111820"/>
-                </a:solidFill>
-                <a:latin typeface="Calibri"/>
-              </a:rPr>
-              <a:t>Screen 3: evidence, filters, mutants, reviewer verdict</a:t>
+              <a:rPr sz="1912" b="0">
+                <a:solidFill>
+                  <a:srgbClr val="111820"/>
+                </a:solidFill>
+                <a:latin typeface="Calibri"/>
+              </a:rPr>
+              <a:t>Screen 3: evidence, filters, mutants, reviewer verdict; screen 5: the first wrong turn and the trace links</a:t>
             </a:r>
           </a:p>
           <a:p>
             <a:pPr algn="l">
               <a:spcAft>
-                <a:spcPts val="945"/>
+                <a:spcPts val="860"/>
               </a:spcAft>
             </a:pPr>
             <a:r>
-              <a:rPr sz="2100" b="0">
+              <a:rPr sz="1912" b="0">
                 <a:solidFill>
                   <a:srgbClr val="111820"/>
                 </a:solidFill>
@@ -38407,20 +38584,44 @@
               <a:t>•  </a:t>
             </a:r>
             <a:r>
-              <a:rPr sz="2100" b="0">
-                <a:solidFill>
-                  <a:srgbClr val="111820"/>
-                </a:solidFill>
-                <a:latin typeface="Calibri"/>
-              </a:rPr>
-              <a:t>Screen 5: the first wrong turn and the trace links</a:t>
-            </a:r>
-          </a:p>
-        </p:txBody>
-      </p:sp>
-      <p:sp>
-        <p:nvSpPr>
-          <p:cNvPr id="9" name="Rectangle 8"/>
+              <a:rPr sz="1912" b="0">
+                <a:solidFill>
+                  <a:srgbClr val="111820"/>
+                </a:solidFill>
+                <a:latin typeface="Calibri"/>
+              </a:rPr>
+              <a:t>Console screen 1 (final), captured on 2026-10-17, run ab-20261017-120323-c97138; your output will differ</a:t>
+            </a:r>
+          </a:p>
+        </p:txBody>
+      </p:sp>
+      <p:pic>
+        <p:nvPicPr>
+          <p:cNvPr id="9" name="Picture 8" descr="final-console.png"/>
+          <p:cNvPicPr>
+            <a:picLocks noChangeAspect="1"/>
+          </p:cNvPicPr>
+          <p:nvPr/>
+        </p:nvPicPr>
+        <p:blipFill>
+          <a:blip r:embed="rId2"/>
+          <a:stretch>
+            <a:fillRect/>
+          </a:stretch>
+        </p:blipFill>
+        <p:spPr>
+          <a:xfrm>
+            <a:off x="2942146" y="3233261"/>
+            <a:ext cx="6307708" cy="2691289"/>
+          </a:xfrm>
+          <a:prstGeom prst="rect">
+            <a:avLst/>
+          </a:prstGeom>
+        </p:spPr>
+      </p:pic>
+      <p:sp>
+        <p:nvSpPr>
+          <p:cNvPr id="10" name="Rectangle 9"/>
           <p:cNvSpPr/>
           <p:nvPr/>
         </p:nvSpPr>
@@ -38466,7 +38667,7 @@
       </p:sp>
       <p:sp>
         <p:nvSpPr>
-          <p:cNvPr id="10" name="TextBox 9"/>
+          <p:cNvPr id="11" name="TextBox 10"/>
           <p:cNvSpPr txBox="1"/>
           <p:nvPr/>
         </p:nvSpPr>
@@ -38754,7 +38955,7 @@
         <p:spPr>
           <a:xfrm>
             <a:off x="533400" y="1219200"/>
-            <a:ext cx="11125200" cy="4705350"/>
+            <a:ext cx="11125200" cy="1765554"/>
           </a:xfrm>
           <a:prstGeom prst="rect">
             <a:avLst/>
@@ -38816,11 +39017,60 @@
               <a:t>Look for ⚠ other-org and ⧉ duplicate marks</a:t>
             </a:r>
           </a:p>
-        </p:txBody>
-      </p:sp>
-      <p:sp>
-        <p:nvSpPr>
-          <p:cNvPr id="9" name="Rectangle 8"/>
+          <a:p>
+            <a:pPr algn="l">
+              <a:spcAft>
+                <a:spcPts val="945"/>
+              </a:spcAft>
+            </a:pPr>
+            <a:r>
+              <a:rPr sz="2100" b="0">
+                <a:solidFill>
+                  <a:srgbClr val="111820"/>
+                </a:solidFill>
+                <a:latin typeface="Calibri"/>
+              </a:rPr>
+              <a:t>•  </a:t>
+            </a:r>
+            <a:r>
+              <a:rPr sz="2100" b="0">
+                <a:solidFill>
+                  <a:srgbClr val="111820"/>
+                </a:solidFill>
+                <a:latin typeface="Calibri"/>
+              </a:rPr>
+              <a:t>Console screen 2 (final), captured on 2026-10-17, run ab-20261017-120323-c97138; your output will differ</a:t>
+            </a:r>
+          </a:p>
+        </p:txBody>
+      </p:sp>
+      <p:pic>
+        <p:nvPicPr>
+          <p:cNvPr id="9" name="Picture 8" descr="final-boards.png"/>
+          <p:cNvPicPr>
+            <a:picLocks noChangeAspect="1"/>
+          </p:cNvPicPr>
+          <p:nvPr/>
+        </p:nvPicPr>
+        <p:blipFill>
+          <a:blip r:embed="rId2"/>
+          <a:stretch>
+            <a:fillRect/>
+          </a:stretch>
+        </p:blipFill>
+        <p:spPr>
+          <a:xfrm>
+            <a:off x="2051622" y="3080004"/>
+            <a:ext cx="8088756" cy="2844546"/>
+          </a:xfrm>
+          <a:prstGeom prst="rect">
+            <a:avLst/>
+          </a:prstGeom>
+        </p:spPr>
+      </p:pic>
+      <p:sp>
+        <p:nvSpPr>
+          <p:cNvPr id="10" name="Rectangle 9"/>
           <p:cNvSpPr/>
           <p:nvPr/>
         </p:nvSpPr>
@@ -38866,7 +39116,7 @@
       </p:sp>
       <p:sp>
         <p:nvSpPr>
-          <p:cNvPr id="10" name="TextBox 9"/>
+          <p:cNvPr id="11" name="TextBox 10"/>
           <p:cNvSpPr txBox="1"/>
           <p:nvPr/>
         </p:nvSpPr>
@@ -40372,7 +40622,7 @@
                 </a:solidFill>
                 <a:latin typeface="Calibri"/>
               </a:rPr>
-              <a:t>, ≤ $1.50 and 60 traces</a:t>
+              <a:t>, ≤ $0.40 and 4 traces</a:t>
             </a:r>
           </a:p>
           <a:p>
@@ -40415,7 +40665,7 @@
                 </a:solidFill>
                 <a:latin typeface="Calibri"/>
               </a:rPr>
-              <a:t>, ≤ $0.25 and 30 traces</a:t>
+              <a:t>, ≤ $0.48 and 4 traces</a:t>
             </a:r>
           </a:p>
           <a:p>
@@ -40458,7 +40708,7 @@
                 </a:solidFill>
                 <a:latin typeface="Calibri"/>
               </a:rPr>
-              <a:t>, ≤ $1.75 and 120 traces</a:t>
+              <a:t>, ≤ $0.68</a:t>
             </a:r>
           </a:p>
           <a:p>
@@ -43259,7 +43509,7 @@
         <p:spPr>
           <a:xfrm>
             <a:off x="533400" y="1219200"/>
-            <a:ext cx="11125200" cy="5181600"/>
+            <a:ext cx="11125200" cy="2839517"/>
           </a:xfrm>
           <a:prstGeom prst="rect">
             <a:avLst/>
@@ -43274,11 +43524,11 @@
           <a:p>
             <a:pPr algn="l">
               <a:spcAft>
-                <a:spcPts val="945"/>
+                <a:spcPts val="918"/>
               </a:spcAft>
             </a:pPr>
             <a:r>
-              <a:rPr sz="2100" b="0">
+              <a:rPr sz="2039" b="0">
                 <a:solidFill>
                   <a:srgbClr val="111820"/>
                 </a:solidFill>
@@ -43287,7 +43537,7 @@
               <a:t>•  </a:t>
             </a:r>
             <a:r>
-              <a:rPr sz="2100" b="0">
+              <a:rPr sz="2039" b="0">
                 <a:solidFill>
                   <a:srgbClr val="111820"/>
                 </a:solidFill>
@@ -43296,7 +43546,7 @@
               <a:t>Now: run </a:t>
             </a:r>
             <a:r>
-              <a:rPr sz="2100" b="0">
+              <a:rPr sz="2039" b="0">
                 <a:solidFill>
                   <a:srgbClr val="111820"/>
                 </a:solidFill>
@@ -43305,7 +43555,7 @@
               <a:t>make show-1</a:t>
             </a:r>
             <a:r>
-              <a:rPr sz="2100" b="0">
+              <a:rPr sz="2039" b="0">
                 <a:solidFill>
                   <a:srgbClr val="111820"/>
                 </a:solidFill>
@@ -43317,11 +43567,11 @@
           <a:p>
             <a:pPr algn="l">
               <a:spcAft>
-                <a:spcPts val="945"/>
+                <a:spcPts val="918"/>
               </a:spcAft>
             </a:pPr>
             <a:r>
-              <a:rPr sz="2100" b="0">
+              <a:rPr sz="2039" b="0">
                 <a:solidFill>
                   <a:srgbClr val="111820"/>
                 </a:solidFill>
@@ -43330,7 +43580,7 @@
               <a:t>•  </a:t>
             </a:r>
             <a:r>
-              <a:rPr sz="2100" b="0">
+              <a:rPr sz="2039" b="0">
                 <a:solidFill>
                   <a:srgbClr val="111820"/>
                 </a:solidFill>
@@ -43342,11 +43592,11 @@
           <a:p>
             <a:pPr algn="l">
               <a:spcAft>
-                <a:spcPts val="945"/>
+                <a:spcPts val="918"/>
               </a:spcAft>
             </a:pPr>
             <a:r>
-              <a:rPr sz="2100" b="0">
+              <a:rPr sz="2039" b="0">
                 <a:solidFill>
                   <a:srgbClr val="111820"/>
                 </a:solidFill>
@@ -43355,23 +43605,23 @@
               <a:t>•  </a:t>
             </a:r>
             <a:r>
-              <a:rPr sz="2100" b="0">
-                <a:solidFill>
-                  <a:srgbClr val="111820"/>
-                </a:solidFill>
-                <a:latin typeface="Calibri"/>
-              </a:rPr>
-              <a:t>Watch for: the agent reads the map, then only the documents the ticket needs</a:t>
+              <a:rPr sz="2039" b="0">
+                <a:solidFill>
+                  <a:srgbClr val="111820"/>
+                </a:solidFill>
+                <a:latin typeface="Calibri"/>
+              </a:rPr>
+              <a:t>Watch for: the map is in its context from the first turn; which documents does it open before it writes code?</a:t>
             </a:r>
           </a:p>
           <a:p>
             <a:pPr algn="l">
               <a:spcAft>
-                <a:spcPts val="945"/>
+                <a:spcPts val="918"/>
               </a:spcAft>
             </a:pPr>
             <a:r>
-              <a:rPr sz="2100" b="0">
+              <a:rPr sz="2039" b="0">
                 <a:solidFill>
                   <a:srgbClr val="111820"/>
                 </a:solidFill>
@@ -43380,17 +43630,41 @@
               <a:t>•  </a:t>
             </a:r>
             <a:r>
-              <a:rPr sz="2100" b="0">
-                <a:solidFill>
-                  <a:srgbClr val="111820"/>
-                </a:solidFill>
-                <a:latin typeface="Calibri"/>
-              </a:rPr>
-              <a:t>Harness arm layers: instructions; the referee still judges the run (R1 probes, hidden tests, mutants)</a:t>
-            </a:r>
-          </a:p>
-        </p:txBody>
-      </p:sp>
+              <a:rPr sz="2039" b="0">
+                <a:solidFill>
+                  <a:srgbClr val="111820"/>
+                </a:solidFill>
+                <a:latin typeface="Calibri"/>
+              </a:rPr>
+              <a:t>The referee judges it live: R1 probes first ("primary verdict ready"), then the other checks</a:t>
+            </a:r>
+          </a:p>
+        </p:txBody>
+      </p:sp>
+      <p:pic>
+        <p:nvPicPr>
+          <p:cNvPr id="9" name="Picture 8" descr="f0edb3aded035d1f.png"/>
+          <p:cNvPicPr>
+            <a:picLocks noChangeAspect="1"/>
+          </p:cNvPicPr>
+          <p:nvPr/>
+        </p:nvPicPr>
+        <p:blipFill>
+          <a:blip r:embed="rId2"/>
+          <a:stretch>
+            <a:fillRect/>
+          </a:stretch>
+        </p:blipFill>
+        <p:spPr>
+          <a:xfrm>
+            <a:off x="533400" y="4936524"/>
+            <a:ext cx="11125200" cy="681719"/>
+          </a:xfrm>
+          <a:prstGeom prst="rect">
+            <a:avLst/>
+          </a:prstGeom>
+        </p:spPr>
+      </p:pic>
     </p:spTree>
   </p:cSld>
   <p:clrMapOvr>

</xml_diff>

<commit_message>
instructor, slides: the S4:gate excerpt re-pulled at 143-184; deck rebuilt
</commit_message>
<xml_diff>
--- a/slides/deck.pptx
+++ b/slides/deck.pptx
@@ -36451,7 +36451,7 @@
                 </a:solidFill>
                 <a:latin typeface="Consolas"/>
               </a:rPr>
-              <a:t>items.append(clean)</a:t>
+              <a:t>passed = not any(i.status == "fail" for i in items)</a:t>
             </a:r>
           </a:p>
           <a:p>
@@ -36463,7 +36463,7 @@
                 </a:solidFill>
                 <a:latin typeface="Consolas"/>
               </a:rPr>
-              <a:t>if clean.status == "fail":</a:t>
+              <a:t>feedback = "" if passed else _feedback(gate_id, items, lines)</a:t>
             </a:r>
           </a:p>
           <a:p>
@@ -36475,7 +36475,7 @@
                 </a:solidFill>
                 <a:latin typeface="Consolas"/>
               </a:rPr>
-              <a:t>    lines.append(f"FAIL clean state: {clean.detail}")</a:t>
+              <a:t>result = GateResult(gate_id=gate_id, items=items, passed=passed, feedback=feedback)</a:t>
             </a:r>
           </a:p>
           <a:p>
@@ -36487,7 +36487,7 @@
                 </a:solidFill>
                 <a:latin typeface="Consolas"/>
               </a:rPr>
-              <a:t>    ...</a:t>
+              <a:t>...</a:t>
             </a:r>
           </a:p>
           <a:p>
@@ -36499,7 +36499,7 @@
                 </a:solidFill>
                 <a:latin typeface="Consolas"/>
               </a:rPr>
-              <a:t>passed = not any(i.status == "fail" for i in items)</a:t>
+              <a:t>    on_update(result)</a:t>
             </a:r>
           </a:p>
         </p:txBody>

</xml_diff>